<commit_message>
Brand SAST workflow as BugBori
</commit_message>
<xml_diff>
--- a/reports/AI_Multi_Agent_SAST_UserLand.pptx
+++ b/reports/AI_Multi_Agent_SAST_UserLand.pptx
@@ -2,20 +2,20 @@
 <file path=ppt/presentation.xml><?xml version="1.0" encoding="utf-8"?>
 <p:presentation xmlns:p="http://schemas.openxmlformats.org/presentationml/2006/main">
   <p:sldMasterIdLst>
-    <p:sldMasterId xmlns:r="http://schemas.openxmlformats.org/officeDocument/2006/relationships" id="2147483648" r:id="R5acead58107e48b3"/>
+    <p:sldMasterId xmlns:r="http://schemas.openxmlformats.org/officeDocument/2006/relationships" id="2147483648" r:id="Rfbfbc334de594ee9"/>
   </p:sldMasterIdLst>
   <p:notesMasterIdLst>
-    <p:notesMasterId xmlns:r="http://schemas.openxmlformats.org/officeDocument/2006/relationships" r:id="R10cd4eb7ddd14f37"/>
+    <p:notesMasterId xmlns:r="http://schemas.openxmlformats.org/officeDocument/2006/relationships" r:id="R1f2f2615df074238"/>
   </p:notesMasterIdLst>
   <p:sldIdLst>
-    <p:sldId xmlns:r="http://schemas.openxmlformats.org/officeDocument/2006/relationships" id="256" r:id="R8c63bc38717b4f6c"/>
-    <p:sldId xmlns:r="http://schemas.openxmlformats.org/officeDocument/2006/relationships" id="257" r:id="Ra616d5f50cab4105"/>
-    <p:sldId xmlns:r="http://schemas.openxmlformats.org/officeDocument/2006/relationships" id="258" r:id="R7ee3fb1e6bd54b0e"/>
-    <p:sldId xmlns:r="http://schemas.openxmlformats.org/officeDocument/2006/relationships" id="259" r:id="Rd63ac5f8f8124aa9"/>
-    <p:sldId xmlns:r="http://schemas.openxmlformats.org/officeDocument/2006/relationships" id="260" r:id="R59b21c91777a45b1"/>
-    <p:sldId xmlns:r="http://schemas.openxmlformats.org/officeDocument/2006/relationships" id="261" r:id="R4c99d004bbcc41df"/>
-    <p:sldId xmlns:r="http://schemas.openxmlformats.org/officeDocument/2006/relationships" id="262" r:id="Rb16b43e309714ce3"/>
-    <p:sldId xmlns:r="http://schemas.openxmlformats.org/officeDocument/2006/relationships" id="263" r:id="R325187944d184ddb"/>
+    <p:sldId xmlns:r="http://schemas.openxmlformats.org/officeDocument/2006/relationships" id="256" r:id="R2383a26fe1ce49b0"/>
+    <p:sldId xmlns:r="http://schemas.openxmlformats.org/officeDocument/2006/relationships" id="257" r:id="R8979c78d165043b1"/>
+    <p:sldId xmlns:r="http://schemas.openxmlformats.org/officeDocument/2006/relationships" id="258" r:id="Rd089921adf1b43a5"/>
+    <p:sldId xmlns:r="http://schemas.openxmlformats.org/officeDocument/2006/relationships" id="259" r:id="R70b068122b3e45c4"/>
+    <p:sldId xmlns:r="http://schemas.openxmlformats.org/officeDocument/2006/relationships" id="260" r:id="Rd35e6bafc260414c"/>
+    <p:sldId xmlns:r="http://schemas.openxmlformats.org/officeDocument/2006/relationships" id="261" r:id="R7392f7058ce84ee0"/>
+    <p:sldId xmlns:r="http://schemas.openxmlformats.org/officeDocument/2006/relationships" id="262" r:id="R1fb2ef1a50af42bb"/>
+    <p:sldId xmlns:r="http://schemas.openxmlformats.org/officeDocument/2006/relationships" id="263" r:id="Ref611fa40b404037"/>
   </p:sldIdLst>
   <p:sldSz cx="12192000" cy="6858000"/>
   <p:notesSz cx="6858000" cy="9144000"/>
@@ -975,7 +975,7 @@
   </p:cSld>
   <p:clrMap bg1="lt1" tx1="dk1" bg2="lt2" tx2="dk2" accent1="accent1" accent2="accent2" accent3="accent3" accent4="accent4" accent5="accent5" accent6="accent6" hlink="hlink" folHlink="folHlink"/>
   <p:sldLayoutIdLst>
-    <p:sldLayoutId xmlns:r="http://schemas.openxmlformats.org/officeDocument/2006/relationships" id="2147483649" r:id="Reecf3968bc034e18"/>
+    <p:sldLayoutId xmlns:r="http://schemas.openxmlformats.org/officeDocument/2006/relationships" id="2147483649" r:id="Rf404ea6c03814753"/>
   </p:sldLayoutIdLst>
   <p:txStyles>
     <p:titleStyle>
@@ -1526,7 +1526,7 @@
           <p:cNvPr id="14" name="">
             <a:extLst xmlns:a="http://schemas.openxmlformats.org/drawingml/2006/main">
               <a:ext uri="{FF2B5EF4-FFF2-40B4-BE49-F238E27FC236}">
-                <a16:creationId xmlns:a16="http://schemas.microsoft.com/office/drawing/2014/main" id="{A065FA53-4E8E-4B18-A1E0-E9D9FC1297D5}"/>
+                <a16:creationId xmlns:a16="http://schemas.microsoft.com/office/drawing/2014/main" id="{B3608637-E41A-455C-938F-EB3DF60B0080}"/>
               </a:ext>
             </a:extLst>
           </p:cNvPr>
@@ -1559,7 +1559,7 @@
           <p:cNvPr id="2" name="">
             <a:extLst xmlns:a="http://schemas.openxmlformats.org/drawingml/2006/main">
               <a:ext uri="{FF2B5EF4-FFF2-40B4-BE49-F238E27FC236}">
-                <a16:creationId xmlns:a16="http://schemas.microsoft.com/office/drawing/2014/main" id="{DEB978FD-6341-4A68-BF8C-3C673B53BD5E}"/>
+                <a16:creationId xmlns:a16="http://schemas.microsoft.com/office/drawing/2014/main" id="{E1E6C218-E129-4AD5-B5E2-B84284A4467D}"/>
               </a:ext>
             </a:extLst>
           </p:cNvPr>
@@ -1599,7 +1599,7 @@
                   <a:srgbClr val="FFFFFF"/>
                 </a:solidFill>
               </a:rPr>
-              <a:t>SAST 과제 · 제출용 발표</a:t>
+              <a:t>BugBori · SAST 과제</a:t>
             </a:r>
           </a:p>
         </p:txBody>
@@ -1609,7 +1609,7 @@
           <p:cNvPr id="3" name="">
             <a:extLst xmlns:a="http://schemas.openxmlformats.org/drawingml/2006/main">
               <a:ext uri="{FF2B5EF4-FFF2-40B4-BE49-F238E27FC236}">
-                <a16:creationId xmlns:a16="http://schemas.microsoft.com/office/drawing/2014/main" id="{C9BD9329-E7E4-4DF3-BAC1-289C61E1FCF9}"/>
+                <a16:creationId xmlns:a16="http://schemas.microsoft.com/office/drawing/2014/main" id="{FB91D73E-CB6F-475B-9AA2-1149E4217741}"/>
               </a:ext>
             </a:extLst>
           </p:cNvPr>
@@ -1649,7 +1649,7 @@
                   <a:srgbClr val="171717"/>
                 </a:solidFill>
               </a:rPr>
-              <a:t>AI 기반</a:t>
+              <a:t>BugBori</a:t>
             </a:r>
           </a:p>
           <a:p xmlns:a="http://schemas.openxmlformats.org/drawingml/2006/main">
@@ -1666,7 +1666,7 @@
                   <a:srgbClr val="171717"/>
                 </a:solidFill>
               </a:rPr>
-              <a:t>Multi-Agent SAST</a:t>
+              <a:t>AI 기반 SAST</a:t>
             </a:r>
           </a:p>
         </p:txBody>
@@ -1676,7 +1676,7 @@
           <p:cNvPr id="4" name="">
             <a:extLst xmlns:a="http://schemas.openxmlformats.org/drawingml/2006/main">
               <a:ext uri="{FF2B5EF4-FFF2-40B4-BE49-F238E27FC236}">
-                <a16:creationId xmlns:a16="http://schemas.microsoft.com/office/drawing/2014/main" id="{5CF9025B-9801-4A1D-A2A0-41A4A2F3EDB3}"/>
+                <a16:creationId xmlns:a16="http://schemas.microsoft.com/office/drawing/2014/main" id="{3182F687-60AE-488B-B07F-62AEA77D3339}"/>
               </a:ext>
             </a:extLst>
           </p:cNvPr>
@@ -1726,7 +1726,7 @@
           <p:cNvPr id="5" name="">
             <a:extLst xmlns:a="http://schemas.openxmlformats.org/drawingml/2006/main">
               <a:ext uri="{FF2B5EF4-FFF2-40B4-BE49-F238E27FC236}">
-                <a16:creationId xmlns:a16="http://schemas.microsoft.com/office/drawing/2014/main" id="{6A4EE7C6-F776-49BF-A2DA-62DE8E7F088C}"/>
+                <a16:creationId xmlns:a16="http://schemas.microsoft.com/office/drawing/2014/main" id="{56AD6CD2-EC21-4CFD-A22B-4B91AB456BFB}"/>
               </a:ext>
             </a:extLst>
           </p:cNvPr>
@@ -1757,7 +1757,7 @@
           <p:cNvPr id="6" name="">
             <a:extLst xmlns:a="http://schemas.openxmlformats.org/drawingml/2006/main">
               <a:ext uri="{FF2B5EF4-FFF2-40B4-BE49-F238E27FC236}">
-                <a16:creationId xmlns:a16="http://schemas.microsoft.com/office/drawing/2014/main" id="{3323667C-16FD-4931-8D49-4A654FC77E43}"/>
+                <a16:creationId xmlns:a16="http://schemas.microsoft.com/office/drawing/2014/main" id="{D96C114E-5D7D-4BBF-979B-CBF65D2E1200}"/>
               </a:ext>
             </a:extLst>
           </p:cNvPr>
@@ -1807,7 +1807,7 @@
           <p:cNvPr id="7" name="">
             <a:extLst xmlns:a="http://schemas.openxmlformats.org/drawingml/2006/main">
               <a:ext uri="{FF2B5EF4-FFF2-40B4-BE49-F238E27FC236}">
-                <a16:creationId xmlns:a16="http://schemas.microsoft.com/office/drawing/2014/main" id="{9F4B2D68-3D86-4DE6-8C7A-1C4B3758E796}"/>
+                <a16:creationId xmlns:a16="http://schemas.microsoft.com/office/drawing/2014/main" id="{B0C621B7-BE7F-4022-AAFF-EFF5E6F08485}"/>
               </a:ext>
             </a:extLst>
           </p:cNvPr>
@@ -1840,7 +1840,7 @@
           <p:cNvPr id="8" name="">
             <a:extLst xmlns:a="http://schemas.openxmlformats.org/drawingml/2006/main">
               <a:ext uri="{FF2B5EF4-FFF2-40B4-BE49-F238E27FC236}">
-                <a16:creationId xmlns:a16="http://schemas.microsoft.com/office/drawing/2014/main" id="{13BABB04-ACFD-4ED2-97C2-77D6538FB6A2}"/>
+                <a16:creationId xmlns:a16="http://schemas.microsoft.com/office/drawing/2014/main" id="{464810F0-2466-46A7-8E1A-4AA3A24240CA}"/>
               </a:ext>
             </a:extLst>
           </p:cNvPr>
@@ -1890,7 +1890,7 @@
           <p:cNvPr id="9" name="">
             <a:extLst xmlns:a="http://schemas.openxmlformats.org/drawingml/2006/main">
               <a:ext uri="{FF2B5EF4-FFF2-40B4-BE49-F238E27FC236}">
-                <a16:creationId xmlns:a16="http://schemas.microsoft.com/office/drawing/2014/main" id="{33A32B25-1637-4F3B-8C1B-5BFFA4782517}"/>
+                <a16:creationId xmlns:a16="http://schemas.microsoft.com/office/drawing/2014/main" id="{5962C706-E02B-4E9F-8C6D-9756A268B41B}"/>
               </a:ext>
             </a:extLst>
           </p:cNvPr>
@@ -1923,7 +1923,7 @@
           <p:cNvPr id="10" name="">
             <a:extLst xmlns:a="http://schemas.openxmlformats.org/drawingml/2006/main">
               <a:ext uri="{FF2B5EF4-FFF2-40B4-BE49-F238E27FC236}">
-                <a16:creationId xmlns:a16="http://schemas.microsoft.com/office/drawing/2014/main" id="{3460AA26-2B80-466B-9BC0-8A217F6FA5C8}"/>
+                <a16:creationId xmlns:a16="http://schemas.microsoft.com/office/drawing/2014/main" id="{75ACF62E-8E32-4350-8F23-14A3186A6052}"/>
               </a:ext>
             </a:extLst>
           </p:cNvPr>
@@ -1973,7 +1973,7 @@
           <p:cNvPr id="11" name="">
             <a:extLst xmlns:a="http://schemas.openxmlformats.org/drawingml/2006/main">
               <a:ext uri="{FF2B5EF4-FFF2-40B4-BE49-F238E27FC236}">
-                <a16:creationId xmlns:a16="http://schemas.microsoft.com/office/drawing/2014/main" id="{81103B08-BD62-4D85-82E7-2E37EEE24E52}"/>
+                <a16:creationId xmlns:a16="http://schemas.microsoft.com/office/drawing/2014/main" id="{BA21C814-C83D-4C01-9875-D779C0095797}"/>
               </a:ext>
             </a:extLst>
           </p:cNvPr>
@@ -2006,7 +2006,7 @@
           <p:cNvPr id="12" name="">
             <a:extLst xmlns:a="http://schemas.openxmlformats.org/drawingml/2006/main">
               <a:ext uri="{FF2B5EF4-FFF2-40B4-BE49-F238E27FC236}">
-                <a16:creationId xmlns:a16="http://schemas.microsoft.com/office/drawing/2014/main" id="{709F7C13-7E3D-4DCF-ACF2-A89EC54836FE}"/>
+                <a16:creationId xmlns:a16="http://schemas.microsoft.com/office/drawing/2014/main" id="{EA7E8F1E-E0DC-4910-A9FD-614915BC0E4B}"/>
               </a:ext>
             </a:extLst>
           </p:cNvPr>
@@ -2056,7 +2056,7 @@
           <p:cNvPr id="13" name="">
             <a:extLst xmlns:a="http://schemas.openxmlformats.org/drawingml/2006/main">
               <a:ext uri="{FF2B5EF4-FFF2-40B4-BE49-F238E27FC236}">
-                <a16:creationId xmlns:a16="http://schemas.microsoft.com/office/drawing/2014/main" id="{D2318CAB-BECC-4CF1-90F4-2C0DB3BBFDF0}"/>
+                <a16:creationId xmlns:a16="http://schemas.microsoft.com/office/drawing/2014/main" id="{4B3982F1-1731-411F-A645-359AFA5D9D62}"/>
               </a:ext>
             </a:extLst>
           </p:cNvPr>
@@ -2104,7 +2104,7 @@
     </p:spTree>
     <p:extLst>
       <p:ext uri="{BB962C8B-B14F-4D97-AF65-F5344CB8AC3E}">
-        <p14:creationId xmlns:p14="http://schemas.microsoft.com/office/powerpoint/2010/main" val="809034650"/>
+        <p14:creationId xmlns:p14="http://schemas.microsoft.com/office/powerpoint/2010/main" val="682327697"/>
       </p:ext>
     </p:extLst>
   </p:cSld>
@@ -2135,7 +2135,7 @@
           <p:cNvPr id="18" name="">
             <a:extLst xmlns:a="http://schemas.openxmlformats.org/drawingml/2006/main">
               <a:ext uri="{FF2B5EF4-FFF2-40B4-BE49-F238E27FC236}">
-                <a16:creationId xmlns:a16="http://schemas.microsoft.com/office/drawing/2014/main" id="{C6788744-D5F2-43D9-87D0-5DDBF988D160}"/>
+                <a16:creationId xmlns:a16="http://schemas.microsoft.com/office/drawing/2014/main" id="{D21A1C0E-E9E8-4ABC-A161-580B83250C69}"/>
               </a:ext>
             </a:extLst>
           </p:cNvPr>
@@ -2185,7 +2185,7 @@
           <p:cNvPr id="2" name="">
             <a:extLst xmlns:a="http://schemas.openxmlformats.org/drawingml/2006/main">
               <a:ext uri="{FF2B5EF4-FFF2-40B4-BE49-F238E27FC236}">
-                <a16:creationId xmlns:a16="http://schemas.microsoft.com/office/drawing/2014/main" id="{86594315-784E-49B9-A2EB-477B14C84F4C}"/>
+                <a16:creationId xmlns:a16="http://schemas.microsoft.com/office/drawing/2014/main" id="{A5CD9F21-224C-4FEC-B215-7D66AE979DED}"/>
               </a:ext>
             </a:extLst>
           </p:cNvPr>
@@ -2235,7 +2235,7 @@
           <p:cNvPr id="3" name="">
             <a:extLst xmlns:a="http://schemas.openxmlformats.org/drawingml/2006/main">
               <a:ext uri="{FF2B5EF4-FFF2-40B4-BE49-F238E27FC236}">
-                <a16:creationId xmlns:a16="http://schemas.microsoft.com/office/drawing/2014/main" id="{95784C15-81DC-4FAD-A314-EF4D42826DE8}"/>
+                <a16:creationId xmlns:a16="http://schemas.microsoft.com/office/drawing/2014/main" id="{E3EA194E-F1B6-4295-AA01-9BC495EB3EED}"/>
               </a:ext>
             </a:extLst>
           </p:cNvPr>
@@ -2285,7 +2285,7 @@
           <p:cNvPr id="4" name="">
             <a:extLst xmlns:a="http://schemas.openxmlformats.org/drawingml/2006/main">
               <a:ext uri="{FF2B5EF4-FFF2-40B4-BE49-F238E27FC236}">
-                <a16:creationId xmlns:a16="http://schemas.microsoft.com/office/drawing/2014/main" id="{F665400B-EA0B-4F2A-80E1-5969C472F8AC}"/>
+                <a16:creationId xmlns:a16="http://schemas.microsoft.com/office/drawing/2014/main" id="{CE8B01C8-6C25-45DE-88A9-7DBB06CD1FB1}"/>
               </a:ext>
             </a:extLst>
           </p:cNvPr>
@@ -2316,7 +2316,7 @@
           <p:cNvPr id="5" name="">
             <a:extLst xmlns:a="http://schemas.openxmlformats.org/drawingml/2006/main">
               <a:ext uri="{FF2B5EF4-FFF2-40B4-BE49-F238E27FC236}">
-                <a16:creationId xmlns:a16="http://schemas.microsoft.com/office/drawing/2014/main" id="{3AF38DA9-F2B8-4DE5-82A2-A66762DD0F7F}"/>
+                <a16:creationId xmlns:a16="http://schemas.microsoft.com/office/drawing/2014/main" id="{5F8D8C75-AD73-464F-8A0B-61B8E0506A6D}"/>
               </a:ext>
             </a:extLst>
           </p:cNvPr>
@@ -2366,7 +2366,7 @@
           <p:cNvPr id="6" name="">
             <a:extLst xmlns:a="http://schemas.openxmlformats.org/drawingml/2006/main">
               <a:ext uri="{FF2B5EF4-FFF2-40B4-BE49-F238E27FC236}">
-                <a16:creationId xmlns:a16="http://schemas.microsoft.com/office/drawing/2014/main" id="{F69E1404-9953-4D07-99FC-772C2E504B88}"/>
+                <a16:creationId xmlns:a16="http://schemas.microsoft.com/office/drawing/2014/main" id="{8B5D26D5-8CA9-4661-956F-C1B083784D74}"/>
               </a:ext>
             </a:extLst>
           </p:cNvPr>
@@ -2416,7 +2416,7 @@
           <p:cNvPr id="7" name="">
             <a:extLst xmlns:a="http://schemas.openxmlformats.org/drawingml/2006/main">
               <a:ext uri="{FF2B5EF4-FFF2-40B4-BE49-F238E27FC236}">
-                <a16:creationId xmlns:a16="http://schemas.microsoft.com/office/drawing/2014/main" id="{BEE4B20C-6C1C-42B5-AC29-780EADDDE4A5}"/>
+                <a16:creationId xmlns:a16="http://schemas.microsoft.com/office/drawing/2014/main" id="{4351BCC3-54D5-4ECD-B68E-A5345FF1B270}"/>
               </a:ext>
             </a:extLst>
           </p:cNvPr>
@@ -2466,7 +2466,7 @@
           <p:cNvPr id="8" name="">
             <a:extLst xmlns:a="http://schemas.openxmlformats.org/drawingml/2006/main">
               <a:ext uri="{FF2B5EF4-FFF2-40B4-BE49-F238E27FC236}">
-                <a16:creationId xmlns:a16="http://schemas.microsoft.com/office/drawing/2014/main" id="{CE43A187-565C-4915-8E9B-D9F1457C0410}"/>
+                <a16:creationId xmlns:a16="http://schemas.microsoft.com/office/drawing/2014/main" id="{184F987D-5E62-4841-87BE-566570C408E5}"/>
               </a:ext>
             </a:extLst>
           </p:cNvPr>
@@ -2516,7 +2516,7 @@
           <p:cNvPr id="9" name="">
             <a:extLst xmlns:a="http://schemas.openxmlformats.org/drawingml/2006/main">
               <a:ext uri="{FF2B5EF4-FFF2-40B4-BE49-F238E27FC236}">
-                <a16:creationId xmlns:a16="http://schemas.microsoft.com/office/drawing/2014/main" id="{7B85832C-F607-44B0-AD17-5A2E34F8D565}"/>
+                <a16:creationId xmlns:a16="http://schemas.microsoft.com/office/drawing/2014/main" id="{C5F0ADD3-A9A3-410F-B1C4-A9542D6F9B92}"/>
               </a:ext>
             </a:extLst>
           </p:cNvPr>
@@ -2566,7 +2566,7 @@
           <p:cNvPr id="10" name="">
             <a:extLst xmlns:a="http://schemas.openxmlformats.org/drawingml/2006/main">
               <a:ext uri="{FF2B5EF4-FFF2-40B4-BE49-F238E27FC236}">
-                <a16:creationId xmlns:a16="http://schemas.microsoft.com/office/drawing/2014/main" id="{A24F28C2-8A6E-4D23-98F4-88806D908CDE}"/>
+                <a16:creationId xmlns:a16="http://schemas.microsoft.com/office/drawing/2014/main" id="{8E844D72-5202-4630-906A-9C5C6C8EAA52}"/>
               </a:ext>
             </a:extLst>
           </p:cNvPr>
@@ -2616,7 +2616,7 @@
           <p:cNvPr id="11" name="">
             <a:extLst xmlns:a="http://schemas.openxmlformats.org/drawingml/2006/main">
               <a:ext uri="{FF2B5EF4-FFF2-40B4-BE49-F238E27FC236}">
-                <a16:creationId xmlns:a16="http://schemas.microsoft.com/office/drawing/2014/main" id="{87FD69CC-27BD-4215-9043-CDB1A157E951}"/>
+                <a16:creationId xmlns:a16="http://schemas.microsoft.com/office/drawing/2014/main" id="{85383378-A6BD-4812-AF6A-7E53A2E8A797}"/>
               </a:ext>
             </a:extLst>
           </p:cNvPr>
@@ -2647,7 +2647,7 @@
           <p:cNvPr id="12" name="">
             <a:extLst xmlns:a="http://schemas.openxmlformats.org/drawingml/2006/main">
               <a:ext uri="{FF2B5EF4-FFF2-40B4-BE49-F238E27FC236}">
-                <a16:creationId xmlns:a16="http://schemas.microsoft.com/office/drawing/2014/main" id="{11694977-A711-4D14-8E90-103E46B3F176}"/>
+                <a16:creationId xmlns:a16="http://schemas.microsoft.com/office/drawing/2014/main" id="{ABDEB22D-711D-4909-A7B8-6DBBAC341374}"/>
               </a:ext>
             </a:extLst>
           </p:cNvPr>
@@ -2697,7 +2697,7 @@
           <p:cNvPr id="13" name="">
             <a:extLst xmlns:a="http://schemas.openxmlformats.org/drawingml/2006/main">
               <a:ext uri="{FF2B5EF4-FFF2-40B4-BE49-F238E27FC236}">
-                <a16:creationId xmlns:a16="http://schemas.microsoft.com/office/drawing/2014/main" id="{0515D6B6-F60D-4616-9AFA-34E208C967C6}"/>
+                <a16:creationId xmlns:a16="http://schemas.microsoft.com/office/drawing/2014/main" id="{19313487-B891-46CA-88D9-C8B841EAEFA6}"/>
               </a:ext>
             </a:extLst>
           </p:cNvPr>
@@ -2764,7 +2764,7 @@
           <p:cNvPr id="14" name="">
             <a:extLst xmlns:a="http://schemas.openxmlformats.org/drawingml/2006/main">
               <a:ext uri="{FF2B5EF4-FFF2-40B4-BE49-F238E27FC236}">
-                <a16:creationId xmlns:a16="http://schemas.microsoft.com/office/drawing/2014/main" id="{5B77F4AF-1746-4A6D-9668-05C2001B9EAE}"/>
+                <a16:creationId xmlns:a16="http://schemas.microsoft.com/office/drawing/2014/main" id="{C281302A-14E8-48C9-9174-0A87A7D0C573}"/>
               </a:ext>
             </a:extLst>
           </p:cNvPr>
@@ -2814,7 +2814,7 @@
           <p:cNvPr id="15" name="">
             <a:extLst xmlns:a="http://schemas.openxmlformats.org/drawingml/2006/main">
               <a:ext uri="{FF2B5EF4-FFF2-40B4-BE49-F238E27FC236}">
-                <a16:creationId xmlns:a16="http://schemas.microsoft.com/office/drawing/2014/main" id="{68A1A9BC-3307-4040-8AA5-89D5B0429EF3}"/>
+                <a16:creationId xmlns:a16="http://schemas.microsoft.com/office/drawing/2014/main" id="{FCA25D5E-5417-4CC5-A1BC-3C73B4F61993}"/>
               </a:ext>
             </a:extLst>
           </p:cNvPr>
@@ -2881,7 +2881,7 @@
           <p:cNvPr id="16" name="">
             <a:extLst xmlns:a="http://schemas.openxmlformats.org/drawingml/2006/main">
               <a:ext uri="{FF2B5EF4-FFF2-40B4-BE49-F238E27FC236}">
-                <a16:creationId xmlns:a16="http://schemas.microsoft.com/office/drawing/2014/main" id="{2312190E-7513-4FBC-83CB-88ED85F9EDDC}"/>
+                <a16:creationId xmlns:a16="http://schemas.microsoft.com/office/drawing/2014/main" id="{21F814FB-D4AE-4953-A3C4-40CBE6E3B57C}"/>
               </a:ext>
             </a:extLst>
           </p:cNvPr>
@@ -2914,7 +2914,7 @@
           <p:cNvPr id="17" name="">
             <a:extLst xmlns:a="http://schemas.openxmlformats.org/drawingml/2006/main">
               <a:ext uri="{FF2B5EF4-FFF2-40B4-BE49-F238E27FC236}">
-                <a16:creationId xmlns:a16="http://schemas.microsoft.com/office/drawing/2014/main" id="{30869569-C76D-430D-85B3-3E6CEE93D4BD}"/>
+                <a16:creationId xmlns:a16="http://schemas.microsoft.com/office/drawing/2014/main" id="{36AEE129-E28F-472B-AA16-FA9AD8115595}"/>
               </a:ext>
             </a:extLst>
           </p:cNvPr>
@@ -2962,7 +2962,7 @@
     </p:spTree>
     <p:extLst>
       <p:ext uri="{BB962C8B-B14F-4D97-AF65-F5344CB8AC3E}">
-        <p14:creationId xmlns:p14="http://schemas.microsoft.com/office/powerpoint/2010/main" val="1108705559"/>
+        <p14:creationId xmlns:p14="http://schemas.microsoft.com/office/powerpoint/2010/main" val="366611961"/>
       </p:ext>
     </p:extLst>
   </p:cSld>
@@ -2993,7 +2993,7 @@
           <p:cNvPr id="40" name="">
             <a:extLst xmlns:a="http://schemas.openxmlformats.org/drawingml/2006/main">
               <a:ext uri="{FF2B5EF4-FFF2-40B4-BE49-F238E27FC236}">
-                <a16:creationId xmlns:a16="http://schemas.microsoft.com/office/drawing/2014/main" id="{78C386D2-69B6-4E9A-8BAB-A68A3B966324}"/>
+                <a16:creationId xmlns:a16="http://schemas.microsoft.com/office/drawing/2014/main" id="{71C4C8FC-B472-488A-A95F-8DD5FB5E172E}"/>
               </a:ext>
             </a:extLst>
           </p:cNvPr>
@@ -3043,7 +3043,7 @@
           <p:cNvPr id="2" name="">
             <a:extLst xmlns:a="http://schemas.openxmlformats.org/drawingml/2006/main">
               <a:ext uri="{FF2B5EF4-FFF2-40B4-BE49-F238E27FC236}">
-                <a16:creationId xmlns:a16="http://schemas.microsoft.com/office/drawing/2014/main" id="{2D0A7BEC-1FF1-4787-B59B-10DB28CF8F02}"/>
+                <a16:creationId xmlns:a16="http://schemas.microsoft.com/office/drawing/2014/main" id="{30817CE2-E92A-46F2-9130-97F31B9E1CC4}"/>
               </a:ext>
             </a:extLst>
           </p:cNvPr>
@@ -3093,7 +3093,7 @@
           <p:cNvPr id="3" name="">
             <a:extLst xmlns:a="http://schemas.openxmlformats.org/drawingml/2006/main">
               <a:ext uri="{FF2B5EF4-FFF2-40B4-BE49-F238E27FC236}">
-                <a16:creationId xmlns:a16="http://schemas.microsoft.com/office/drawing/2014/main" id="{039F2CE5-0112-4C0A-A3E5-443B0100BEB1}"/>
+                <a16:creationId xmlns:a16="http://schemas.microsoft.com/office/drawing/2014/main" id="{CED0C0D2-3D20-4ACA-B9D4-E65BC39E2C7E}"/>
               </a:ext>
             </a:extLst>
           </p:cNvPr>
@@ -3143,7 +3143,7 @@
           <p:cNvPr id="4" name="">
             <a:extLst xmlns:a="http://schemas.openxmlformats.org/drawingml/2006/main">
               <a:ext uri="{FF2B5EF4-FFF2-40B4-BE49-F238E27FC236}">
-                <a16:creationId xmlns:a16="http://schemas.microsoft.com/office/drawing/2014/main" id="{77EE8C60-1B5A-44F8-A702-A8B9E1383A36}"/>
+                <a16:creationId xmlns:a16="http://schemas.microsoft.com/office/drawing/2014/main" id="{6DF315E9-98C8-4789-BE22-33EE4BE295EC}"/>
               </a:ext>
             </a:extLst>
           </p:cNvPr>
@@ -3174,7 +3174,7 @@
           <p:cNvPr id="5" name="">
             <a:extLst xmlns:a="http://schemas.openxmlformats.org/drawingml/2006/main">
               <a:ext uri="{FF2B5EF4-FFF2-40B4-BE49-F238E27FC236}">
-                <a16:creationId xmlns:a16="http://schemas.microsoft.com/office/drawing/2014/main" id="{42D41CA0-DB9A-4495-8C8A-4F6B75C32AA7}"/>
+                <a16:creationId xmlns:a16="http://schemas.microsoft.com/office/drawing/2014/main" id="{E117B0C2-F111-4651-A485-F8DEA8A89542}"/>
               </a:ext>
             </a:extLst>
           </p:cNvPr>
@@ -3205,7 +3205,7 @@
           <p:cNvPr id="6" name="">
             <a:extLst xmlns:a="http://schemas.openxmlformats.org/drawingml/2006/main">
               <a:ext uri="{FF2B5EF4-FFF2-40B4-BE49-F238E27FC236}">
-                <a16:creationId xmlns:a16="http://schemas.microsoft.com/office/drawing/2014/main" id="{81EFA230-705F-4437-894E-2E410E633F02}"/>
+                <a16:creationId xmlns:a16="http://schemas.microsoft.com/office/drawing/2014/main" id="{E7E31F26-FE12-4432-B010-CE70481CB952}"/>
               </a:ext>
             </a:extLst>
           </p:cNvPr>
@@ -3236,7 +3236,7 @@
           <p:cNvPr id="7" name="">
             <a:extLst xmlns:a="http://schemas.openxmlformats.org/drawingml/2006/main">
               <a:ext uri="{FF2B5EF4-FFF2-40B4-BE49-F238E27FC236}">
-                <a16:creationId xmlns:a16="http://schemas.microsoft.com/office/drawing/2014/main" id="{7F348EFC-9207-4F46-A718-0A4E89811EA5}"/>
+                <a16:creationId xmlns:a16="http://schemas.microsoft.com/office/drawing/2014/main" id="{82B1B803-1D54-46F5-AEB1-BE4823D6AB8E}"/>
               </a:ext>
             </a:extLst>
           </p:cNvPr>
@@ -3267,7 +3267,7 @@
           <p:cNvPr id="8" name="">
             <a:extLst xmlns:a="http://schemas.openxmlformats.org/drawingml/2006/main">
               <a:ext uri="{FF2B5EF4-FFF2-40B4-BE49-F238E27FC236}">
-                <a16:creationId xmlns:a16="http://schemas.microsoft.com/office/drawing/2014/main" id="{7D8682E3-7A77-4CD1-9DAC-EE40EBC311A1}"/>
+                <a16:creationId xmlns:a16="http://schemas.microsoft.com/office/drawing/2014/main" id="{207DAC29-532B-47A4-A304-81CE67C89E79}"/>
               </a:ext>
             </a:extLst>
           </p:cNvPr>
@@ -3298,7 +3298,7 @@
           <p:cNvPr id="9" name="">
             <a:extLst xmlns:a="http://schemas.openxmlformats.org/drawingml/2006/main">
               <a:ext uri="{FF2B5EF4-FFF2-40B4-BE49-F238E27FC236}">
-                <a16:creationId xmlns:a16="http://schemas.microsoft.com/office/drawing/2014/main" id="{851CDD91-1A58-432C-8560-A4D3298BD48E}"/>
+                <a16:creationId xmlns:a16="http://schemas.microsoft.com/office/drawing/2014/main" id="{2C1422EE-7736-4A28-853B-CB6353959604}"/>
               </a:ext>
             </a:extLst>
           </p:cNvPr>
@@ -3329,7 +3329,7 @@
           <p:cNvPr id="10" name="">
             <a:extLst xmlns:a="http://schemas.openxmlformats.org/drawingml/2006/main">
               <a:ext uri="{FF2B5EF4-FFF2-40B4-BE49-F238E27FC236}">
-                <a16:creationId xmlns:a16="http://schemas.microsoft.com/office/drawing/2014/main" id="{73959D15-5E06-43A0-8EEF-7E438EEECBEB}"/>
+                <a16:creationId xmlns:a16="http://schemas.microsoft.com/office/drawing/2014/main" id="{70688235-BD10-4239-B7C0-C3E915F59B16}"/>
               </a:ext>
             </a:extLst>
           </p:cNvPr>
@@ -3360,7 +3360,7 @@
           <p:cNvPr id="11" name="">
             <a:extLst xmlns:a="http://schemas.openxmlformats.org/drawingml/2006/main">
               <a:ext uri="{FF2B5EF4-FFF2-40B4-BE49-F238E27FC236}">
-                <a16:creationId xmlns:a16="http://schemas.microsoft.com/office/drawing/2014/main" id="{DBA0D793-D7E2-4CF6-B0E6-6D649D1ACFDE}"/>
+                <a16:creationId xmlns:a16="http://schemas.microsoft.com/office/drawing/2014/main" id="{B2B9FD14-8F2B-4834-9F52-B25111975D80}"/>
               </a:ext>
             </a:extLst>
           </p:cNvPr>
@@ -3391,7 +3391,7 @@
           <p:cNvPr id="12" name="">
             <a:extLst xmlns:a="http://schemas.openxmlformats.org/drawingml/2006/main">
               <a:ext uri="{FF2B5EF4-FFF2-40B4-BE49-F238E27FC236}">
-                <a16:creationId xmlns:a16="http://schemas.microsoft.com/office/drawing/2014/main" id="{68520E41-FF79-4F45-93DF-DDBDAEB1AEF0}"/>
+                <a16:creationId xmlns:a16="http://schemas.microsoft.com/office/drawing/2014/main" id="{80193963-E6AF-47A3-AA61-5A8D7700F702}"/>
               </a:ext>
             </a:extLst>
           </p:cNvPr>
@@ -3422,7 +3422,7 @@
           <p:cNvPr id="13" name="">
             <a:extLst xmlns:a="http://schemas.openxmlformats.org/drawingml/2006/main">
               <a:ext uri="{FF2B5EF4-FFF2-40B4-BE49-F238E27FC236}">
-                <a16:creationId xmlns:a16="http://schemas.microsoft.com/office/drawing/2014/main" id="{494BC9AD-CD42-473A-AD51-9F7C050221E8}"/>
+                <a16:creationId xmlns:a16="http://schemas.microsoft.com/office/drawing/2014/main" id="{FDDB9C1D-E644-4AF9-A9EC-59C3E070686A}"/>
               </a:ext>
             </a:extLst>
           </p:cNvPr>
@@ -3453,7 +3453,7 @@
           <p:cNvPr id="14" name="">
             <a:extLst xmlns:a="http://schemas.openxmlformats.org/drawingml/2006/main">
               <a:ext uri="{FF2B5EF4-FFF2-40B4-BE49-F238E27FC236}">
-                <a16:creationId xmlns:a16="http://schemas.microsoft.com/office/drawing/2014/main" id="{372080C2-69BA-455A-9BE0-8B98B0CC0958}"/>
+                <a16:creationId xmlns:a16="http://schemas.microsoft.com/office/drawing/2014/main" id="{56C4C187-1FA3-403F-99C9-56A6E6812A4D}"/>
               </a:ext>
             </a:extLst>
           </p:cNvPr>
@@ -3484,7 +3484,7 @@
           <p:cNvPr id="15" name="">
             <a:extLst xmlns:a="http://schemas.openxmlformats.org/drawingml/2006/main">
               <a:ext uri="{FF2B5EF4-FFF2-40B4-BE49-F238E27FC236}">
-                <a16:creationId xmlns:a16="http://schemas.microsoft.com/office/drawing/2014/main" id="{64A1F4BD-6E3B-44E8-98C0-90FF7549B20E}"/>
+                <a16:creationId xmlns:a16="http://schemas.microsoft.com/office/drawing/2014/main" id="{4EA839D3-C126-4C2B-9362-0EB6491E9462}"/>
               </a:ext>
             </a:extLst>
           </p:cNvPr>
@@ -3519,7 +3519,7 @@
           <p:cNvPr id="16" name="">
             <a:extLst xmlns:a="http://schemas.openxmlformats.org/drawingml/2006/main">
               <a:ext uri="{FF2B5EF4-FFF2-40B4-BE49-F238E27FC236}">
-                <a16:creationId xmlns:a16="http://schemas.microsoft.com/office/drawing/2014/main" id="{962FC44D-3D61-454A-A16F-16580C0302B8}"/>
+                <a16:creationId xmlns:a16="http://schemas.microsoft.com/office/drawing/2014/main" id="{33E8F2B9-14D3-4064-8617-75A06CDFC89A}"/>
               </a:ext>
             </a:extLst>
           </p:cNvPr>
@@ -3569,7 +3569,7 @@
           <p:cNvPr id="17" name="">
             <a:extLst xmlns:a="http://schemas.openxmlformats.org/drawingml/2006/main">
               <a:ext uri="{FF2B5EF4-FFF2-40B4-BE49-F238E27FC236}">
-                <a16:creationId xmlns:a16="http://schemas.microsoft.com/office/drawing/2014/main" id="{0DAFAB38-CE55-4CD5-A43D-F50FA7373899}"/>
+                <a16:creationId xmlns:a16="http://schemas.microsoft.com/office/drawing/2014/main" id="{67B04A53-AB02-4BCE-845A-E54B69B331A1}"/>
               </a:ext>
             </a:extLst>
           </p:cNvPr>
@@ -3636,7 +3636,7 @@
           <p:cNvPr id="18" name="">
             <a:extLst xmlns:a="http://schemas.openxmlformats.org/drawingml/2006/main">
               <a:ext uri="{FF2B5EF4-FFF2-40B4-BE49-F238E27FC236}">
-                <a16:creationId xmlns:a16="http://schemas.microsoft.com/office/drawing/2014/main" id="{2EA1899C-4324-40F4-A4CB-20B178275031}"/>
+                <a16:creationId xmlns:a16="http://schemas.microsoft.com/office/drawing/2014/main" id="{FF71E465-F88C-49F8-9E9E-474FA7127CB7}"/>
               </a:ext>
             </a:extLst>
           </p:cNvPr>
@@ -3671,7 +3671,7 @@
           <p:cNvPr id="19" name="">
             <a:extLst xmlns:a="http://schemas.openxmlformats.org/drawingml/2006/main">
               <a:ext uri="{FF2B5EF4-FFF2-40B4-BE49-F238E27FC236}">
-                <a16:creationId xmlns:a16="http://schemas.microsoft.com/office/drawing/2014/main" id="{EC8A172F-9A4A-40BC-A6C5-4E9C6E482433}"/>
+                <a16:creationId xmlns:a16="http://schemas.microsoft.com/office/drawing/2014/main" id="{BAD04E3F-A7D2-40AC-9200-FD420646C179}"/>
               </a:ext>
             </a:extLst>
           </p:cNvPr>
@@ -3721,7 +3721,7 @@
           <p:cNvPr id="20" name="">
             <a:extLst xmlns:a="http://schemas.openxmlformats.org/drawingml/2006/main">
               <a:ext uri="{FF2B5EF4-FFF2-40B4-BE49-F238E27FC236}">
-                <a16:creationId xmlns:a16="http://schemas.microsoft.com/office/drawing/2014/main" id="{BDC99E79-8062-4E35-B36B-1342836AFE86}"/>
+                <a16:creationId xmlns:a16="http://schemas.microsoft.com/office/drawing/2014/main" id="{B8CDD038-B630-47E9-BC9E-2C89DE2AB46E}"/>
               </a:ext>
             </a:extLst>
           </p:cNvPr>
@@ -3788,7 +3788,7 @@
           <p:cNvPr id="21" name="">
             <a:extLst xmlns:a="http://schemas.openxmlformats.org/drawingml/2006/main">
               <a:ext uri="{FF2B5EF4-FFF2-40B4-BE49-F238E27FC236}">
-                <a16:creationId xmlns:a16="http://schemas.microsoft.com/office/drawing/2014/main" id="{CD7BC2D2-E258-46CE-95BC-D848AC3297CE}"/>
+                <a16:creationId xmlns:a16="http://schemas.microsoft.com/office/drawing/2014/main" id="{C136F902-B264-47B9-9A01-A84A52E75682}"/>
               </a:ext>
             </a:extLst>
           </p:cNvPr>
@@ -3823,7 +3823,7 @@
           <p:cNvPr id="22" name="">
             <a:extLst xmlns:a="http://schemas.openxmlformats.org/drawingml/2006/main">
               <a:ext uri="{FF2B5EF4-FFF2-40B4-BE49-F238E27FC236}">
-                <a16:creationId xmlns:a16="http://schemas.microsoft.com/office/drawing/2014/main" id="{ADE4192E-265F-46D4-B882-8D46A64417E7}"/>
+                <a16:creationId xmlns:a16="http://schemas.microsoft.com/office/drawing/2014/main" id="{EF7A747C-D3D5-4B4C-BD22-A3FF7A554C66}"/>
               </a:ext>
             </a:extLst>
           </p:cNvPr>
@@ -3873,7 +3873,7 @@
           <p:cNvPr id="23" name="">
             <a:extLst xmlns:a="http://schemas.openxmlformats.org/drawingml/2006/main">
               <a:ext uri="{FF2B5EF4-FFF2-40B4-BE49-F238E27FC236}">
-                <a16:creationId xmlns:a16="http://schemas.microsoft.com/office/drawing/2014/main" id="{D5BBB787-7A46-4AC9-87E1-C5F42CC4A4C4}"/>
+                <a16:creationId xmlns:a16="http://schemas.microsoft.com/office/drawing/2014/main" id="{70397184-BAA1-4483-A90A-6A8FEE4AE027}"/>
               </a:ext>
             </a:extLst>
           </p:cNvPr>
@@ -3940,7 +3940,7 @@
           <p:cNvPr id="24" name="">
             <a:extLst xmlns:a="http://schemas.openxmlformats.org/drawingml/2006/main">
               <a:ext uri="{FF2B5EF4-FFF2-40B4-BE49-F238E27FC236}">
-                <a16:creationId xmlns:a16="http://schemas.microsoft.com/office/drawing/2014/main" id="{D7FE2E3D-BE92-422D-928A-AA49EC3CD302}"/>
+                <a16:creationId xmlns:a16="http://schemas.microsoft.com/office/drawing/2014/main" id="{E90DE634-8249-4503-87CA-762A00D9D51F}"/>
               </a:ext>
             </a:extLst>
           </p:cNvPr>
@@ -3975,7 +3975,7 @@
           <p:cNvPr id="25" name="">
             <a:extLst xmlns:a="http://schemas.openxmlformats.org/drawingml/2006/main">
               <a:ext uri="{FF2B5EF4-FFF2-40B4-BE49-F238E27FC236}">
-                <a16:creationId xmlns:a16="http://schemas.microsoft.com/office/drawing/2014/main" id="{5AA153E3-0898-4BB6-8F16-8162FE151B5D}"/>
+                <a16:creationId xmlns:a16="http://schemas.microsoft.com/office/drawing/2014/main" id="{9D6D779E-8BBA-48AB-87A7-CAACD7283750}"/>
               </a:ext>
             </a:extLst>
           </p:cNvPr>
@@ -4025,7 +4025,7 @@
           <p:cNvPr id="26" name="">
             <a:extLst xmlns:a="http://schemas.openxmlformats.org/drawingml/2006/main">
               <a:ext uri="{FF2B5EF4-FFF2-40B4-BE49-F238E27FC236}">
-                <a16:creationId xmlns:a16="http://schemas.microsoft.com/office/drawing/2014/main" id="{472DD062-608E-4F88-AA57-3A7D6AA11AE7}"/>
+                <a16:creationId xmlns:a16="http://schemas.microsoft.com/office/drawing/2014/main" id="{BC819A26-93BB-402C-B0A7-1A7A0340E5A2}"/>
               </a:ext>
             </a:extLst>
           </p:cNvPr>
@@ -4092,7 +4092,7 @@
           <p:cNvPr id="27" name="">
             <a:extLst xmlns:a="http://schemas.openxmlformats.org/drawingml/2006/main">
               <a:ext uri="{FF2B5EF4-FFF2-40B4-BE49-F238E27FC236}">
-                <a16:creationId xmlns:a16="http://schemas.microsoft.com/office/drawing/2014/main" id="{44227D6D-4417-4BFE-9BD6-8A9E163234D3}"/>
+                <a16:creationId xmlns:a16="http://schemas.microsoft.com/office/drawing/2014/main" id="{7E761021-9F5B-4D78-8BC8-B968CCE14C2C}"/>
               </a:ext>
             </a:extLst>
           </p:cNvPr>
@@ -4127,7 +4127,7 @@
           <p:cNvPr id="28" name="">
             <a:extLst xmlns:a="http://schemas.openxmlformats.org/drawingml/2006/main">
               <a:ext uri="{FF2B5EF4-FFF2-40B4-BE49-F238E27FC236}">
-                <a16:creationId xmlns:a16="http://schemas.microsoft.com/office/drawing/2014/main" id="{071D8B6C-8773-406B-957B-4182917BD56F}"/>
+                <a16:creationId xmlns:a16="http://schemas.microsoft.com/office/drawing/2014/main" id="{A6B4F91D-64F2-4807-A09E-643E3F39DCD5}"/>
               </a:ext>
             </a:extLst>
           </p:cNvPr>
@@ -4177,7 +4177,7 @@
           <p:cNvPr id="29" name="">
             <a:extLst xmlns:a="http://schemas.openxmlformats.org/drawingml/2006/main">
               <a:ext uri="{FF2B5EF4-FFF2-40B4-BE49-F238E27FC236}">
-                <a16:creationId xmlns:a16="http://schemas.microsoft.com/office/drawing/2014/main" id="{E08604F6-53AA-4452-86AA-9BD0DBE8539D}"/>
+                <a16:creationId xmlns:a16="http://schemas.microsoft.com/office/drawing/2014/main" id="{DDB0709E-99D4-4AAC-A178-0D1FA2D7333F}"/>
               </a:ext>
             </a:extLst>
           </p:cNvPr>
@@ -4244,7 +4244,7 @@
           <p:cNvPr id="30" name="">
             <a:extLst xmlns:a="http://schemas.openxmlformats.org/drawingml/2006/main">
               <a:ext uri="{FF2B5EF4-FFF2-40B4-BE49-F238E27FC236}">
-                <a16:creationId xmlns:a16="http://schemas.microsoft.com/office/drawing/2014/main" id="{6519E16F-58AA-4632-A643-8B7458709E28}"/>
+                <a16:creationId xmlns:a16="http://schemas.microsoft.com/office/drawing/2014/main" id="{D28F60C5-8FC7-4EE8-BAFF-782277B2A239}"/>
               </a:ext>
             </a:extLst>
           </p:cNvPr>
@@ -4279,7 +4279,7 @@
           <p:cNvPr id="31" name="">
             <a:extLst xmlns:a="http://schemas.openxmlformats.org/drawingml/2006/main">
               <a:ext uri="{FF2B5EF4-FFF2-40B4-BE49-F238E27FC236}">
-                <a16:creationId xmlns:a16="http://schemas.microsoft.com/office/drawing/2014/main" id="{D5E2FBDC-A9CA-4F81-BA97-D8AD896EBE82}"/>
+                <a16:creationId xmlns:a16="http://schemas.microsoft.com/office/drawing/2014/main" id="{DFA88695-021E-48E0-A4B6-A461138C1944}"/>
               </a:ext>
             </a:extLst>
           </p:cNvPr>
@@ -4329,7 +4329,7 @@
           <p:cNvPr id="32" name="">
             <a:extLst xmlns:a="http://schemas.openxmlformats.org/drawingml/2006/main">
               <a:ext uri="{FF2B5EF4-FFF2-40B4-BE49-F238E27FC236}">
-                <a16:creationId xmlns:a16="http://schemas.microsoft.com/office/drawing/2014/main" id="{14A65801-8ABC-4569-98A8-677FFBCB4558}"/>
+                <a16:creationId xmlns:a16="http://schemas.microsoft.com/office/drawing/2014/main" id="{B433FBA1-D7DA-4DE2-9A19-44DD90EA4595}"/>
               </a:ext>
             </a:extLst>
           </p:cNvPr>
@@ -4396,7 +4396,7 @@
           <p:cNvPr id="33" name="">
             <a:extLst xmlns:a="http://schemas.openxmlformats.org/drawingml/2006/main">
               <a:ext uri="{FF2B5EF4-FFF2-40B4-BE49-F238E27FC236}">
-                <a16:creationId xmlns:a16="http://schemas.microsoft.com/office/drawing/2014/main" id="{2B03CD78-2048-4705-BA8A-5173FDAEE60E}"/>
+                <a16:creationId xmlns:a16="http://schemas.microsoft.com/office/drawing/2014/main" id="{B1A3A76E-E996-4912-AE4C-888A07C35D40}"/>
               </a:ext>
             </a:extLst>
           </p:cNvPr>
@@ -4446,7 +4446,7 @@
           <p:cNvPr id="34" name="">
             <a:extLst xmlns:a="http://schemas.openxmlformats.org/drawingml/2006/main">
               <a:ext uri="{FF2B5EF4-FFF2-40B4-BE49-F238E27FC236}">
-                <a16:creationId xmlns:a16="http://schemas.microsoft.com/office/drawing/2014/main" id="{0AA98C51-D569-4C54-A7AB-9027F8F6F7E0}"/>
+                <a16:creationId xmlns:a16="http://schemas.microsoft.com/office/drawing/2014/main" id="{BA6075A7-1F1C-4C89-9386-57AB783A5BBB}"/>
               </a:ext>
             </a:extLst>
           </p:cNvPr>
@@ -4496,7 +4496,7 @@
           <p:cNvPr id="35" name="">
             <a:extLst xmlns:a="http://schemas.openxmlformats.org/drawingml/2006/main">
               <a:ext uri="{FF2B5EF4-FFF2-40B4-BE49-F238E27FC236}">
-                <a16:creationId xmlns:a16="http://schemas.microsoft.com/office/drawing/2014/main" id="{97ED064F-C426-437B-9507-67125C587A7E}"/>
+                <a16:creationId xmlns:a16="http://schemas.microsoft.com/office/drawing/2014/main" id="{67830568-2032-43CF-8532-709F0FC62BB6}"/>
               </a:ext>
             </a:extLst>
           </p:cNvPr>
@@ -4546,7 +4546,7 @@
           <p:cNvPr id="36" name="">
             <a:extLst xmlns:a="http://schemas.openxmlformats.org/drawingml/2006/main">
               <a:ext uri="{FF2B5EF4-FFF2-40B4-BE49-F238E27FC236}">
-                <a16:creationId xmlns:a16="http://schemas.microsoft.com/office/drawing/2014/main" id="{554B8EEC-080E-49CB-840B-F9B50213B3D0}"/>
+                <a16:creationId xmlns:a16="http://schemas.microsoft.com/office/drawing/2014/main" id="{ACE26D64-8ACC-4AD7-81E0-11EA03358313}"/>
               </a:ext>
             </a:extLst>
           </p:cNvPr>
@@ -4596,7 +4596,7 @@
           <p:cNvPr id="37" name="">
             <a:extLst xmlns:a="http://schemas.openxmlformats.org/drawingml/2006/main">
               <a:ext uri="{FF2B5EF4-FFF2-40B4-BE49-F238E27FC236}">
-                <a16:creationId xmlns:a16="http://schemas.microsoft.com/office/drawing/2014/main" id="{75DD55BA-A1DF-4865-A2C4-34B54F571A6D}"/>
+                <a16:creationId xmlns:a16="http://schemas.microsoft.com/office/drawing/2014/main" id="{BF0EA1A1-C6D3-4066-B667-7E40F16F80B7}"/>
               </a:ext>
             </a:extLst>
           </p:cNvPr>
@@ -4627,7 +4627,7 @@
           <p:cNvPr id="38" name="">
             <a:extLst xmlns:a="http://schemas.openxmlformats.org/drawingml/2006/main">
               <a:ext uri="{FF2B5EF4-FFF2-40B4-BE49-F238E27FC236}">
-                <a16:creationId xmlns:a16="http://schemas.microsoft.com/office/drawing/2014/main" id="{CB0EDA95-08F2-46E6-B672-6003CC3B7538}"/>
+                <a16:creationId xmlns:a16="http://schemas.microsoft.com/office/drawing/2014/main" id="{CB2E7B24-A355-4E8E-AD0F-E18F090ED052}"/>
               </a:ext>
             </a:extLst>
           </p:cNvPr>
@@ -4677,7 +4677,7 @@
           <p:cNvPr id="39" name="">
             <a:extLst xmlns:a="http://schemas.openxmlformats.org/drawingml/2006/main">
               <a:ext uri="{FF2B5EF4-FFF2-40B4-BE49-F238E27FC236}">
-                <a16:creationId xmlns:a16="http://schemas.microsoft.com/office/drawing/2014/main" id="{7427C608-C96B-4607-9397-184AADF627EB}"/>
+                <a16:creationId xmlns:a16="http://schemas.microsoft.com/office/drawing/2014/main" id="{D52B31FE-2A27-401C-8200-459B76E52B78}"/>
               </a:ext>
             </a:extLst>
           </p:cNvPr>
@@ -4725,7 +4725,7 @@
     </p:spTree>
     <p:extLst>
       <p:ext uri="{BB962C8B-B14F-4D97-AF65-F5344CB8AC3E}">
-        <p14:creationId xmlns:p14="http://schemas.microsoft.com/office/powerpoint/2010/main" val="1472775499"/>
+        <p14:creationId xmlns:p14="http://schemas.microsoft.com/office/powerpoint/2010/main" val="1356140506"/>
       </p:ext>
     </p:extLst>
   </p:cSld>
@@ -4756,7 +4756,7 @@
           <p:cNvPr id="30" name="">
             <a:extLst xmlns:a="http://schemas.openxmlformats.org/drawingml/2006/main">
               <a:ext uri="{FF2B5EF4-FFF2-40B4-BE49-F238E27FC236}">
-                <a16:creationId xmlns:a16="http://schemas.microsoft.com/office/drawing/2014/main" id="{9175A9EC-1DC1-4962-84F4-AA0AFD603583}"/>
+                <a16:creationId xmlns:a16="http://schemas.microsoft.com/office/drawing/2014/main" id="{1F278E66-B59F-49C8-AC96-61594D9F44CB}"/>
               </a:ext>
             </a:extLst>
           </p:cNvPr>
@@ -4806,7 +4806,7 @@
           <p:cNvPr id="2" name="">
             <a:extLst xmlns:a="http://schemas.openxmlformats.org/drawingml/2006/main">
               <a:ext uri="{FF2B5EF4-FFF2-40B4-BE49-F238E27FC236}">
-                <a16:creationId xmlns:a16="http://schemas.microsoft.com/office/drawing/2014/main" id="{39D2E2CB-0511-4F4D-A04F-ABF8ED790B35}"/>
+                <a16:creationId xmlns:a16="http://schemas.microsoft.com/office/drawing/2014/main" id="{69777A97-8E59-4B4E-84F3-C54439B5CC1A}"/>
               </a:ext>
             </a:extLst>
           </p:cNvPr>
@@ -4856,7 +4856,7 @@
           <p:cNvPr id="3" name="">
             <a:extLst xmlns:a="http://schemas.openxmlformats.org/drawingml/2006/main">
               <a:ext uri="{FF2B5EF4-FFF2-40B4-BE49-F238E27FC236}">
-                <a16:creationId xmlns:a16="http://schemas.microsoft.com/office/drawing/2014/main" id="{3801CCFD-63A7-408C-9EFB-BCBACB429077}"/>
+                <a16:creationId xmlns:a16="http://schemas.microsoft.com/office/drawing/2014/main" id="{26FF1CFC-AA2A-4190-8271-03AA3713BAA6}"/>
               </a:ext>
             </a:extLst>
           </p:cNvPr>
@@ -4906,7 +4906,7 @@
           <p:cNvPr id="4" name="">
             <a:extLst xmlns:a="http://schemas.openxmlformats.org/drawingml/2006/main">
               <a:ext uri="{FF2B5EF4-FFF2-40B4-BE49-F238E27FC236}">
-                <a16:creationId xmlns:a16="http://schemas.microsoft.com/office/drawing/2014/main" id="{5F990E00-A911-4C1B-A9DF-194446393E66}"/>
+                <a16:creationId xmlns:a16="http://schemas.microsoft.com/office/drawing/2014/main" id="{F6D4A5D4-093D-432E-99F8-008F527936DA}"/>
               </a:ext>
             </a:extLst>
           </p:cNvPr>
@@ -4937,7 +4937,7 @@
           <p:cNvPr id="5" name="">
             <a:extLst xmlns:a="http://schemas.openxmlformats.org/drawingml/2006/main">
               <a:ext uri="{FF2B5EF4-FFF2-40B4-BE49-F238E27FC236}">
-                <a16:creationId xmlns:a16="http://schemas.microsoft.com/office/drawing/2014/main" id="{173C578B-E93E-4D33-8560-F849515B590E}"/>
+                <a16:creationId xmlns:a16="http://schemas.microsoft.com/office/drawing/2014/main" id="{D1882507-5A60-460C-A53D-ECD6B8A95CD0}"/>
               </a:ext>
             </a:extLst>
           </p:cNvPr>
@@ -4970,7 +4970,7 @@
           <p:cNvPr id="6" name="">
             <a:extLst xmlns:a="http://schemas.openxmlformats.org/drawingml/2006/main">
               <a:ext uri="{FF2B5EF4-FFF2-40B4-BE49-F238E27FC236}">
-                <a16:creationId xmlns:a16="http://schemas.microsoft.com/office/drawing/2014/main" id="{73E492EB-E3B1-46A0-A5DC-D122D06ACD63}"/>
+                <a16:creationId xmlns:a16="http://schemas.microsoft.com/office/drawing/2014/main" id="{31D2AEAC-C82B-459B-8652-B9FC080D85BF}"/>
               </a:ext>
             </a:extLst>
           </p:cNvPr>
@@ -5020,7 +5020,7 @@
           <p:cNvPr id="7" name="">
             <a:extLst xmlns:a="http://schemas.openxmlformats.org/drawingml/2006/main">
               <a:ext uri="{FF2B5EF4-FFF2-40B4-BE49-F238E27FC236}">
-                <a16:creationId xmlns:a16="http://schemas.microsoft.com/office/drawing/2014/main" id="{1D93C5A7-05E1-42CD-9137-6F7400E7B080}"/>
+                <a16:creationId xmlns:a16="http://schemas.microsoft.com/office/drawing/2014/main" id="{9C97E036-59AF-445D-A96B-435D9E919E46}"/>
               </a:ext>
             </a:extLst>
           </p:cNvPr>
@@ -5055,7 +5055,7 @@
           <p:cNvPr id="8" name="">
             <a:extLst xmlns:a="http://schemas.openxmlformats.org/drawingml/2006/main">
               <a:ext uri="{FF2B5EF4-FFF2-40B4-BE49-F238E27FC236}">
-                <a16:creationId xmlns:a16="http://schemas.microsoft.com/office/drawing/2014/main" id="{575C24B9-F726-40BB-B387-33B463AEF828}"/>
+                <a16:creationId xmlns:a16="http://schemas.microsoft.com/office/drawing/2014/main" id="{DF742B6C-7458-4A73-92D4-AC0F28D79A1C}"/>
               </a:ext>
             </a:extLst>
           </p:cNvPr>
@@ -5105,7 +5105,7 @@
           <p:cNvPr id="9" name="">
             <a:extLst xmlns:a="http://schemas.openxmlformats.org/drawingml/2006/main">
               <a:ext uri="{FF2B5EF4-FFF2-40B4-BE49-F238E27FC236}">
-                <a16:creationId xmlns:a16="http://schemas.microsoft.com/office/drawing/2014/main" id="{B2BB5330-F5ED-4C8A-9891-A6DDBC2D71EF}"/>
+                <a16:creationId xmlns:a16="http://schemas.microsoft.com/office/drawing/2014/main" id="{0C3A3952-DE31-4ECC-BEBB-61C41D5858CA}"/>
               </a:ext>
             </a:extLst>
           </p:cNvPr>
@@ -5155,7 +5155,7 @@
           <p:cNvPr id="10" name="">
             <a:extLst xmlns:a="http://schemas.openxmlformats.org/drawingml/2006/main">
               <a:ext uri="{FF2B5EF4-FFF2-40B4-BE49-F238E27FC236}">
-                <a16:creationId xmlns:a16="http://schemas.microsoft.com/office/drawing/2014/main" id="{19346F7C-0A0B-4F33-84A1-95969FFDC20C}"/>
+                <a16:creationId xmlns:a16="http://schemas.microsoft.com/office/drawing/2014/main" id="{C963313B-B66B-45CE-A19A-40806FE505CA}"/>
               </a:ext>
             </a:extLst>
           </p:cNvPr>
@@ -5205,7 +5205,7 @@
           <p:cNvPr id="11" name="">
             <a:extLst xmlns:a="http://schemas.openxmlformats.org/drawingml/2006/main">
               <a:ext uri="{FF2B5EF4-FFF2-40B4-BE49-F238E27FC236}">
-                <a16:creationId xmlns:a16="http://schemas.microsoft.com/office/drawing/2014/main" id="{1205EE0E-D237-4F8D-9455-47CD2F719B28}"/>
+                <a16:creationId xmlns:a16="http://schemas.microsoft.com/office/drawing/2014/main" id="{3F4FF240-CD4F-4BDA-AEF5-CA56080AD919}"/>
               </a:ext>
             </a:extLst>
           </p:cNvPr>
@@ -5238,7 +5238,7 @@
           <p:cNvPr id="12" name="">
             <a:extLst xmlns:a="http://schemas.openxmlformats.org/drawingml/2006/main">
               <a:ext uri="{FF2B5EF4-FFF2-40B4-BE49-F238E27FC236}">
-                <a16:creationId xmlns:a16="http://schemas.microsoft.com/office/drawing/2014/main" id="{A30BA8A6-B46E-4864-96C2-2B8D68D92A00}"/>
+                <a16:creationId xmlns:a16="http://schemas.microsoft.com/office/drawing/2014/main" id="{BE536BF5-3EB6-4174-8E6B-C526CAE26D4C}"/>
               </a:ext>
             </a:extLst>
           </p:cNvPr>
@@ -5288,7 +5288,7 @@
           <p:cNvPr id="13" name="">
             <a:extLst xmlns:a="http://schemas.openxmlformats.org/drawingml/2006/main">
               <a:ext uri="{FF2B5EF4-FFF2-40B4-BE49-F238E27FC236}">
-                <a16:creationId xmlns:a16="http://schemas.microsoft.com/office/drawing/2014/main" id="{61D3882A-BD6E-4A6A-BE07-DB85DC4644D8}"/>
+                <a16:creationId xmlns:a16="http://schemas.microsoft.com/office/drawing/2014/main" id="{82169B1F-2ECC-4056-A92A-5258B72E1041}"/>
               </a:ext>
             </a:extLst>
           </p:cNvPr>
@@ -5338,7 +5338,7 @@
           <p:cNvPr id="14" name="">
             <a:extLst xmlns:a="http://schemas.openxmlformats.org/drawingml/2006/main">
               <a:ext uri="{FF2B5EF4-FFF2-40B4-BE49-F238E27FC236}">
-                <a16:creationId xmlns:a16="http://schemas.microsoft.com/office/drawing/2014/main" id="{C6F0947B-A20D-4446-B732-7720AB3B2B1E}"/>
+                <a16:creationId xmlns:a16="http://schemas.microsoft.com/office/drawing/2014/main" id="{E69D8AD5-34F2-4838-8902-C2FCF7B896AF}"/>
               </a:ext>
             </a:extLst>
           </p:cNvPr>
@@ -5373,7 +5373,7 @@
           <p:cNvPr id="15" name="">
             <a:extLst xmlns:a="http://schemas.openxmlformats.org/drawingml/2006/main">
               <a:ext uri="{FF2B5EF4-FFF2-40B4-BE49-F238E27FC236}">
-                <a16:creationId xmlns:a16="http://schemas.microsoft.com/office/drawing/2014/main" id="{8735D0EC-8933-4E70-9E6C-C539A33D1939}"/>
+                <a16:creationId xmlns:a16="http://schemas.microsoft.com/office/drawing/2014/main" id="{FA1D7C0E-03A7-4B88-866A-F15B0526996D}"/>
               </a:ext>
             </a:extLst>
           </p:cNvPr>
@@ -5423,7 +5423,7 @@
           <p:cNvPr id="16" name="">
             <a:extLst xmlns:a="http://schemas.openxmlformats.org/drawingml/2006/main">
               <a:ext uri="{FF2B5EF4-FFF2-40B4-BE49-F238E27FC236}">
-                <a16:creationId xmlns:a16="http://schemas.microsoft.com/office/drawing/2014/main" id="{938E9CEF-5B3F-44F2-8769-14DE35E85CBE}"/>
+                <a16:creationId xmlns:a16="http://schemas.microsoft.com/office/drawing/2014/main" id="{9DA43506-7075-4F0A-9FAB-369B7CE2D2F6}"/>
               </a:ext>
             </a:extLst>
           </p:cNvPr>
@@ -5473,7 +5473,7 @@
           <p:cNvPr id="17" name="">
             <a:extLst xmlns:a="http://schemas.openxmlformats.org/drawingml/2006/main">
               <a:ext uri="{FF2B5EF4-FFF2-40B4-BE49-F238E27FC236}">
-                <a16:creationId xmlns:a16="http://schemas.microsoft.com/office/drawing/2014/main" id="{6D2C70F3-8BB1-4D91-BE1F-7D17B4E3C2EF}"/>
+                <a16:creationId xmlns:a16="http://schemas.microsoft.com/office/drawing/2014/main" id="{825990DC-F66F-468A-9E8F-B76A0DD9C062}"/>
               </a:ext>
             </a:extLst>
           </p:cNvPr>
@@ -5523,7 +5523,7 @@
           <p:cNvPr id="18" name="">
             <a:extLst xmlns:a="http://schemas.openxmlformats.org/drawingml/2006/main">
               <a:ext uri="{FF2B5EF4-FFF2-40B4-BE49-F238E27FC236}">
-                <a16:creationId xmlns:a16="http://schemas.microsoft.com/office/drawing/2014/main" id="{089E3D0B-1EB8-4C5A-80F6-26E6FFD27EA0}"/>
+                <a16:creationId xmlns:a16="http://schemas.microsoft.com/office/drawing/2014/main" id="{2A1FBB30-5C89-4EA7-B20C-339ED319C143}"/>
               </a:ext>
             </a:extLst>
           </p:cNvPr>
@@ -5556,7 +5556,7 @@
           <p:cNvPr id="19" name="">
             <a:extLst xmlns:a="http://schemas.openxmlformats.org/drawingml/2006/main">
               <a:ext uri="{FF2B5EF4-FFF2-40B4-BE49-F238E27FC236}">
-                <a16:creationId xmlns:a16="http://schemas.microsoft.com/office/drawing/2014/main" id="{5E067E48-E147-42EB-B906-44D9720DC48F}"/>
+                <a16:creationId xmlns:a16="http://schemas.microsoft.com/office/drawing/2014/main" id="{5F87DD1E-B0DA-451C-BE19-EC57F5999395}"/>
               </a:ext>
             </a:extLst>
           </p:cNvPr>
@@ -5606,7 +5606,7 @@
           <p:cNvPr id="20" name="">
             <a:extLst xmlns:a="http://schemas.openxmlformats.org/drawingml/2006/main">
               <a:ext uri="{FF2B5EF4-FFF2-40B4-BE49-F238E27FC236}">
-                <a16:creationId xmlns:a16="http://schemas.microsoft.com/office/drawing/2014/main" id="{D9B0B8F4-3362-4D2E-BD53-EF39F4264D74}"/>
+                <a16:creationId xmlns:a16="http://schemas.microsoft.com/office/drawing/2014/main" id="{812DD80A-1BC2-4D96-A9A5-7C77DFCFB6C8}"/>
               </a:ext>
             </a:extLst>
           </p:cNvPr>
@@ -5656,7 +5656,7 @@
           <p:cNvPr id="21" name="">
             <a:extLst xmlns:a="http://schemas.openxmlformats.org/drawingml/2006/main">
               <a:ext uri="{FF2B5EF4-FFF2-40B4-BE49-F238E27FC236}">
-                <a16:creationId xmlns:a16="http://schemas.microsoft.com/office/drawing/2014/main" id="{51114A06-E6A4-4EA8-9DB4-AB19D7B3EFF7}"/>
+                <a16:creationId xmlns:a16="http://schemas.microsoft.com/office/drawing/2014/main" id="{CABDC600-5C32-4FDB-AB47-4015D9BAD3BB}"/>
               </a:ext>
             </a:extLst>
           </p:cNvPr>
@@ -5691,7 +5691,7 @@
           <p:cNvPr id="22" name="">
             <a:extLst xmlns:a="http://schemas.openxmlformats.org/drawingml/2006/main">
               <a:ext uri="{FF2B5EF4-FFF2-40B4-BE49-F238E27FC236}">
-                <a16:creationId xmlns:a16="http://schemas.microsoft.com/office/drawing/2014/main" id="{B4DBF524-B49B-4483-9E99-F9DCB4BA620F}"/>
+                <a16:creationId xmlns:a16="http://schemas.microsoft.com/office/drawing/2014/main" id="{FFF500E0-B2FD-4B74-B569-61F5252DEE8A}"/>
               </a:ext>
             </a:extLst>
           </p:cNvPr>
@@ -5741,7 +5741,7 @@
           <p:cNvPr id="23" name="">
             <a:extLst xmlns:a="http://schemas.openxmlformats.org/drawingml/2006/main">
               <a:ext uri="{FF2B5EF4-FFF2-40B4-BE49-F238E27FC236}">
-                <a16:creationId xmlns:a16="http://schemas.microsoft.com/office/drawing/2014/main" id="{3748B918-F3AD-4F09-9FD3-F8A2B3217CF3}"/>
+                <a16:creationId xmlns:a16="http://schemas.microsoft.com/office/drawing/2014/main" id="{41290CC3-ECE5-45B9-994F-7168FDBD0996}"/>
               </a:ext>
             </a:extLst>
           </p:cNvPr>
@@ -5791,7 +5791,7 @@
           <p:cNvPr id="24" name="">
             <a:extLst xmlns:a="http://schemas.openxmlformats.org/drawingml/2006/main">
               <a:ext uri="{FF2B5EF4-FFF2-40B4-BE49-F238E27FC236}">
-                <a16:creationId xmlns:a16="http://schemas.microsoft.com/office/drawing/2014/main" id="{96894100-03CD-4445-8C75-A33EA9406E4A}"/>
+                <a16:creationId xmlns:a16="http://schemas.microsoft.com/office/drawing/2014/main" id="{BD843B91-3A28-4035-A9E4-23C03106EF06}"/>
               </a:ext>
             </a:extLst>
           </p:cNvPr>
@@ -5841,7 +5841,7 @@
           <p:cNvPr id="25" name="">
             <a:extLst xmlns:a="http://schemas.openxmlformats.org/drawingml/2006/main">
               <a:ext uri="{FF2B5EF4-FFF2-40B4-BE49-F238E27FC236}">
-                <a16:creationId xmlns:a16="http://schemas.microsoft.com/office/drawing/2014/main" id="{22AC5797-F9C3-41A1-ADB0-A5A4621C89B5}"/>
+                <a16:creationId xmlns:a16="http://schemas.microsoft.com/office/drawing/2014/main" id="{E68659CF-0CA4-44ED-A618-994B59FCDAF3}"/>
               </a:ext>
             </a:extLst>
           </p:cNvPr>
@@ -5874,7 +5874,7 @@
           <p:cNvPr id="26" name="">
             <a:extLst xmlns:a="http://schemas.openxmlformats.org/drawingml/2006/main">
               <a:ext uri="{FF2B5EF4-FFF2-40B4-BE49-F238E27FC236}">
-                <a16:creationId xmlns:a16="http://schemas.microsoft.com/office/drawing/2014/main" id="{FC29B4D9-51B0-4269-8C05-CEE9D02FAFFD}"/>
+                <a16:creationId xmlns:a16="http://schemas.microsoft.com/office/drawing/2014/main" id="{134FF1D9-FB7A-4CB5-8E6E-D61867F3536E}"/>
               </a:ext>
             </a:extLst>
           </p:cNvPr>
@@ -5924,7 +5924,7 @@
           <p:cNvPr id="27" name="">
             <a:extLst xmlns:a="http://schemas.openxmlformats.org/drawingml/2006/main">
               <a:ext uri="{FF2B5EF4-FFF2-40B4-BE49-F238E27FC236}">
-                <a16:creationId xmlns:a16="http://schemas.microsoft.com/office/drawing/2014/main" id="{1CE1FB29-0D9E-4D69-9046-10D8CD80FA28}"/>
+                <a16:creationId xmlns:a16="http://schemas.microsoft.com/office/drawing/2014/main" id="{6CB2497E-FB00-4E99-8805-75DBDA4ED708}"/>
               </a:ext>
             </a:extLst>
           </p:cNvPr>
@@ -5974,7 +5974,7 @@
           <p:cNvPr id="28" name="">
             <a:extLst xmlns:a="http://schemas.openxmlformats.org/drawingml/2006/main">
               <a:ext uri="{FF2B5EF4-FFF2-40B4-BE49-F238E27FC236}">
-                <a16:creationId xmlns:a16="http://schemas.microsoft.com/office/drawing/2014/main" id="{9808893B-E7B5-4AE5-B93A-53B75EF7D32D}"/>
+                <a16:creationId xmlns:a16="http://schemas.microsoft.com/office/drawing/2014/main" id="{4BA22F95-C5E1-45F6-ABC4-D3CAC4DA1CDE}"/>
               </a:ext>
             </a:extLst>
           </p:cNvPr>
@@ -6024,7 +6024,7 @@
           <p:cNvPr id="29" name="">
             <a:extLst xmlns:a="http://schemas.openxmlformats.org/drawingml/2006/main">
               <a:ext uri="{FF2B5EF4-FFF2-40B4-BE49-F238E27FC236}">
-                <a16:creationId xmlns:a16="http://schemas.microsoft.com/office/drawing/2014/main" id="{722DF681-93AA-4C89-AAB6-4FC7A250D84E}"/>
+                <a16:creationId xmlns:a16="http://schemas.microsoft.com/office/drawing/2014/main" id="{53699447-FAF9-43DA-9005-4DF17BAFFCEF}"/>
               </a:ext>
             </a:extLst>
           </p:cNvPr>
@@ -6072,7 +6072,7 @@
     </p:spTree>
     <p:extLst>
       <p:ext uri="{BB962C8B-B14F-4D97-AF65-F5344CB8AC3E}">
-        <p14:creationId xmlns:p14="http://schemas.microsoft.com/office/powerpoint/2010/main" val="749971570"/>
+        <p14:creationId xmlns:p14="http://schemas.microsoft.com/office/powerpoint/2010/main" val="224095632"/>
       </p:ext>
     </p:extLst>
   </p:cSld>
@@ -6103,7 +6103,7 @@
           <p:cNvPr id="28" name="">
             <a:extLst xmlns:a="http://schemas.openxmlformats.org/drawingml/2006/main">
               <a:ext uri="{FF2B5EF4-FFF2-40B4-BE49-F238E27FC236}">
-                <a16:creationId xmlns:a16="http://schemas.microsoft.com/office/drawing/2014/main" id="{F3B9E542-ECD0-40E8-B45C-054EA6C21BC8}"/>
+                <a16:creationId xmlns:a16="http://schemas.microsoft.com/office/drawing/2014/main" id="{E0B9FDA5-CFDC-47C9-96B5-7E0D219ABAC6}"/>
               </a:ext>
             </a:extLst>
           </p:cNvPr>
@@ -6153,7 +6153,7 @@
           <p:cNvPr id="2" name="">
             <a:extLst xmlns:a="http://schemas.openxmlformats.org/drawingml/2006/main">
               <a:ext uri="{FF2B5EF4-FFF2-40B4-BE49-F238E27FC236}">
-                <a16:creationId xmlns:a16="http://schemas.microsoft.com/office/drawing/2014/main" id="{9F33F7B9-91DB-40D6-889C-F9070346B69E}"/>
+                <a16:creationId xmlns:a16="http://schemas.microsoft.com/office/drawing/2014/main" id="{B61A8788-4506-4150-936D-6A771A66A90C}"/>
               </a:ext>
             </a:extLst>
           </p:cNvPr>
@@ -6203,7 +6203,7 @@
           <p:cNvPr id="3" name="">
             <a:extLst xmlns:a="http://schemas.openxmlformats.org/drawingml/2006/main">
               <a:ext uri="{FF2B5EF4-FFF2-40B4-BE49-F238E27FC236}">
-                <a16:creationId xmlns:a16="http://schemas.microsoft.com/office/drawing/2014/main" id="{B0E80D55-AE9E-4895-85B6-2A2E8EA18253}"/>
+                <a16:creationId xmlns:a16="http://schemas.microsoft.com/office/drawing/2014/main" id="{D5F03F46-A08C-4298-A8BD-C6046575F2B2}"/>
               </a:ext>
             </a:extLst>
           </p:cNvPr>
@@ -6253,7 +6253,7 @@
           <p:cNvPr id="4" name="">
             <a:extLst xmlns:a="http://schemas.openxmlformats.org/drawingml/2006/main">
               <a:ext uri="{FF2B5EF4-FFF2-40B4-BE49-F238E27FC236}">
-                <a16:creationId xmlns:a16="http://schemas.microsoft.com/office/drawing/2014/main" id="{5E5747FB-F16A-4A6A-BC8D-5A921A303EB6}"/>
+                <a16:creationId xmlns:a16="http://schemas.microsoft.com/office/drawing/2014/main" id="{B76F2346-BEA2-4D9F-989E-D469716C9D3E}"/>
               </a:ext>
             </a:extLst>
           </p:cNvPr>
@@ -6284,7 +6284,7 @@
           <p:cNvPr id="5" name="">
             <a:extLst xmlns:a="http://schemas.openxmlformats.org/drawingml/2006/main">
               <a:ext uri="{FF2B5EF4-FFF2-40B4-BE49-F238E27FC236}">
-                <a16:creationId xmlns:a16="http://schemas.microsoft.com/office/drawing/2014/main" id="{C2C9CC69-A91A-4E2E-BD33-1A48D8634299}"/>
+                <a16:creationId xmlns:a16="http://schemas.microsoft.com/office/drawing/2014/main" id="{1E10F5CF-204B-404F-86FB-BFAEE1FE2A1B}"/>
               </a:ext>
             </a:extLst>
           </p:cNvPr>
@@ -6334,7 +6334,7 @@
           <p:cNvPr id="6" name="">
             <a:extLst xmlns:a="http://schemas.openxmlformats.org/drawingml/2006/main">
               <a:ext uri="{FF2B5EF4-FFF2-40B4-BE49-F238E27FC236}">
-                <a16:creationId xmlns:a16="http://schemas.microsoft.com/office/drawing/2014/main" id="{0BE786C8-C7B6-4B08-ACCD-9B1225326437}"/>
+                <a16:creationId xmlns:a16="http://schemas.microsoft.com/office/drawing/2014/main" id="{FD3AECBA-9899-45C8-A314-FBC5333D199B}"/>
               </a:ext>
             </a:extLst>
           </p:cNvPr>
@@ -6384,7 +6384,7 @@
           <p:cNvPr id="7" name="">
             <a:extLst xmlns:a="http://schemas.openxmlformats.org/drawingml/2006/main">
               <a:ext uri="{FF2B5EF4-FFF2-40B4-BE49-F238E27FC236}">
-                <a16:creationId xmlns:a16="http://schemas.microsoft.com/office/drawing/2014/main" id="{98961580-D49D-4FCA-B50E-DF81AE7A0ACE}"/>
+                <a16:creationId xmlns:a16="http://schemas.microsoft.com/office/drawing/2014/main" id="{8E0FAD5B-1B76-40E9-AFB2-844866466D9C}"/>
               </a:ext>
             </a:extLst>
           </p:cNvPr>
@@ -6434,7 +6434,7 @@
           <p:cNvPr id="8" name="">
             <a:extLst xmlns:a="http://schemas.openxmlformats.org/drawingml/2006/main">
               <a:ext uri="{FF2B5EF4-FFF2-40B4-BE49-F238E27FC236}">
-                <a16:creationId xmlns:a16="http://schemas.microsoft.com/office/drawing/2014/main" id="{562E0925-DE7A-42CD-9766-2A9E880F1264}"/>
+                <a16:creationId xmlns:a16="http://schemas.microsoft.com/office/drawing/2014/main" id="{B2DD837C-8FDF-4110-862E-2D9EB506182E}"/>
               </a:ext>
             </a:extLst>
           </p:cNvPr>
@@ -6465,7 +6465,7 @@
           <p:cNvPr id="9" name="">
             <a:extLst xmlns:a="http://schemas.openxmlformats.org/drawingml/2006/main">
               <a:ext uri="{FF2B5EF4-FFF2-40B4-BE49-F238E27FC236}">
-                <a16:creationId xmlns:a16="http://schemas.microsoft.com/office/drawing/2014/main" id="{AE1BEAC5-45E9-482E-89ED-107E94633BB1}"/>
+                <a16:creationId xmlns:a16="http://schemas.microsoft.com/office/drawing/2014/main" id="{864BDF73-F77C-42CC-8FF4-C885870C12F7}"/>
               </a:ext>
             </a:extLst>
           </p:cNvPr>
@@ -6515,7 +6515,7 @@
           <p:cNvPr id="10" name="">
             <a:extLst xmlns:a="http://schemas.openxmlformats.org/drawingml/2006/main">
               <a:ext uri="{FF2B5EF4-FFF2-40B4-BE49-F238E27FC236}">
-                <a16:creationId xmlns:a16="http://schemas.microsoft.com/office/drawing/2014/main" id="{3CF5BCA9-03CE-4C6D-AB0B-8AC7CC8A024E}"/>
+                <a16:creationId xmlns:a16="http://schemas.microsoft.com/office/drawing/2014/main" id="{9826B8AF-6DB4-4AF5-8AA9-34A032830FF3}"/>
               </a:ext>
             </a:extLst>
           </p:cNvPr>
@@ -6565,7 +6565,7 @@
           <p:cNvPr id="11" name="">
             <a:extLst xmlns:a="http://schemas.openxmlformats.org/drawingml/2006/main">
               <a:ext uri="{FF2B5EF4-FFF2-40B4-BE49-F238E27FC236}">
-                <a16:creationId xmlns:a16="http://schemas.microsoft.com/office/drawing/2014/main" id="{F5BB61A2-E369-4B69-B58A-044E8B4AB71C}"/>
+                <a16:creationId xmlns:a16="http://schemas.microsoft.com/office/drawing/2014/main" id="{F7EAF5A5-9957-40F7-8C20-79FB8FC79157}"/>
               </a:ext>
             </a:extLst>
           </p:cNvPr>
@@ -6615,7 +6615,7 @@
           <p:cNvPr id="12" name="">
             <a:extLst xmlns:a="http://schemas.openxmlformats.org/drawingml/2006/main">
               <a:ext uri="{FF2B5EF4-FFF2-40B4-BE49-F238E27FC236}">
-                <a16:creationId xmlns:a16="http://schemas.microsoft.com/office/drawing/2014/main" id="{24563941-FE4A-48CB-8942-8A9FB1923FEA}"/>
+                <a16:creationId xmlns:a16="http://schemas.microsoft.com/office/drawing/2014/main" id="{705CDA25-CE8F-434A-883E-2FD941FB5999}"/>
               </a:ext>
             </a:extLst>
           </p:cNvPr>
@@ -6646,7 +6646,7 @@
           <p:cNvPr id="13" name="">
             <a:extLst xmlns:a="http://schemas.openxmlformats.org/drawingml/2006/main">
               <a:ext uri="{FF2B5EF4-FFF2-40B4-BE49-F238E27FC236}">
-                <a16:creationId xmlns:a16="http://schemas.microsoft.com/office/drawing/2014/main" id="{C5D017DC-2EBF-40D3-AC40-DFF20FDDD8D7}"/>
+                <a16:creationId xmlns:a16="http://schemas.microsoft.com/office/drawing/2014/main" id="{113BB43A-6C8D-47B2-836A-32CABC889DA6}"/>
               </a:ext>
             </a:extLst>
           </p:cNvPr>
@@ -6696,7 +6696,7 @@
           <p:cNvPr id="14" name="">
             <a:extLst xmlns:a="http://schemas.openxmlformats.org/drawingml/2006/main">
               <a:ext uri="{FF2B5EF4-FFF2-40B4-BE49-F238E27FC236}">
-                <a16:creationId xmlns:a16="http://schemas.microsoft.com/office/drawing/2014/main" id="{05E7DFE0-2C36-43E0-82D6-2D46C6C34AE9}"/>
+                <a16:creationId xmlns:a16="http://schemas.microsoft.com/office/drawing/2014/main" id="{57DC8B3C-F4DC-49B2-848D-CAD12E60FDE7}"/>
               </a:ext>
             </a:extLst>
           </p:cNvPr>
@@ -6746,7 +6746,7 @@
           <p:cNvPr id="15" name="">
             <a:extLst xmlns:a="http://schemas.openxmlformats.org/drawingml/2006/main">
               <a:ext uri="{FF2B5EF4-FFF2-40B4-BE49-F238E27FC236}">
-                <a16:creationId xmlns:a16="http://schemas.microsoft.com/office/drawing/2014/main" id="{114174DC-EE27-4F7D-918B-BA2B06A19B8C}"/>
+                <a16:creationId xmlns:a16="http://schemas.microsoft.com/office/drawing/2014/main" id="{DC0A3402-0C40-4728-9B91-DC3762CAB1F6}"/>
               </a:ext>
             </a:extLst>
           </p:cNvPr>
@@ -6796,7 +6796,7 @@
           <p:cNvPr id="16" name="">
             <a:extLst xmlns:a="http://schemas.openxmlformats.org/drawingml/2006/main">
               <a:ext uri="{FF2B5EF4-FFF2-40B4-BE49-F238E27FC236}">
-                <a16:creationId xmlns:a16="http://schemas.microsoft.com/office/drawing/2014/main" id="{14E345E8-EAA9-49B8-A5CB-61AD8EDAA3F7}"/>
+                <a16:creationId xmlns:a16="http://schemas.microsoft.com/office/drawing/2014/main" id="{1186E15D-7787-4E0B-82EA-2B8DD38B02DC}"/>
               </a:ext>
             </a:extLst>
           </p:cNvPr>
@@ -6827,7 +6827,7 @@
           <p:cNvPr id="17" name="">
             <a:extLst xmlns:a="http://schemas.openxmlformats.org/drawingml/2006/main">
               <a:ext uri="{FF2B5EF4-FFF2-40B4-BE49-F238E27FC236}">
-                <a16:creationId xmlns:a16="http://schemas.microsoft.com/office/drawing/2014/main" id="{359BD6FD-B269-45F0-9A42-FF72F4EA093B}"/>
+                <a16:creationId xmlns:a16="http://schemas.microsoft.com/office/drawing/2014/main" id="{92D989C6-60FD-42B5-B64F-CA72D981158C}"/>
               </a:ext>
             </a:extLst>
           </p:cNvPr>
@@ -6877,7 +6877,7 @@
           <p:cNvPr id="18" name="">
             <a:extLst xmlns:a="http://schemas.openxmlformats.org/drawingml/2006/main">
               <a:ext uri="{FF2B5EF4-FFF2-40B4-BE49-F238E27FC236}">
-                <a16:creationId xmlns:a16="http://schemas.microsoft.com/office/drawing/2014/main" id="{749C362D-7327-44E1-A453-705EA6ED477E}"/>
+                <a16:creationId xmlns:a16="http://schemas.microsoft.com/office/drawing/2014/main" id="{231A2021-C43A-4C74-A4B7-A66F1E3FF79A}"/>
               </a:ext>
             </a:extLst>
           </p:cNvPr>
@@ -6927,7 +6927,7 @@
           <p:cNvPr id="19" name="">
             <a:extLst xmlns:a="http://schemas.openxmlformats.org/drawingml/2006/main">
               <a:ext uri="{FF2B5EF4-FFF2-40B4-BE49-F238E27FC236}">
-                <a16:creationId xmlns:a16="http://schemas.microsoft.com/office/drawing/2014/main" id="{B6E859EC-8148-408A-B7E9-12065E83755C}"/>
+                <a16:creationId xmlns:a16="http://schemas.microsoft.com/office/drawing/2014/main" id="{4C90AAFB-ED82-4F25-BCA9-DB2ABEB8F605}"/>
               </a:ext>
             </a:extLst>
           </p:cNvPr>
@@ -6977,7 +6977,7 @@
           <p:cNvPr id="20" name="">
             <a:extLst xmlns:a="http://schemas.openxmlformats.org/drawingml/2006/main">
               <a:ext uri="{FF2B5EF4-FFF2-40B4-BE49-F238E27FC236}">
-                <a16:creationId xmlns:a16="http://schemas.microsoft.com/office/drawing/2014/main" id="{E80974C9-1A58-473E-B33C-2C781B868EC8}"/>
+                <a16:creationId xmlns:a16="http://schemas.microsoft.com/office/drawing/2014/main" id="{AB448457-8283-40DC-89F3-BCCEB1132407}"/>
               </a:ext>
             </a:extLst>
           </p:cNvPr>
@@ -7008,7 +7008,7 @@
           <p:cNvPr id="21" name="">
             <a:extLst xmlns:a="http://schemas.openxmlformats.org/drawingml/2006/main">
               <a:ext uri="{FF2B5EF4-FFF2-40B4-BE49-F238E27FC236}">
-                <a16:creationId xmlns:a16="http://schemas.microsoft.com/office/drawing/2014/main" id="{A076D03D-B1BA-4CAC-A4F6-FDD31A843BD6}"/>
+                <a16:creationId xmlns:a16="http://schemas.microsoft.com/office/drawing/2014/main" id="{2CF3E43E-90FF-4809-92D5-63BC2F67910B}"/>
               </a:ext>
             </a:extLst>
           </p:cNvPr>
@@ -7058,7 +7058,7 @@
           <p:cNvPr id="22" name="">
             <a:extLst xmlns:a="http://schemas.openxmlformats.org/drawingml/2006/main">
               <a:ext uri="{FF2B5EF4-FFF2-40B4-BE49-F238E27FC236}">
-                <a16:creationId xmlns:a16="http://schemas.microsoft.com/office/drawing/2014/main" id="{239FAC7F-1682-4883-99CB-38F5831D9ADD}"/>
+                <a16:creationId xmlns:a16="http://schemas.microsoft.com/office/drawing/2014/main" id="{0EA9F669-6923-4840-941A-267A5C8DC957}"/>
               </a:ext>
             </a:extLst>
           </p:cNvPr>
@@ -7108,7 +7108,7 @@
           <p:cNvPr id="23" name="">
             <a:extLst xmlns:a="http://schemas.openxmlformats.org/drawingml/2006/main">
               <a:ext uri="{FF2B5EF4-FFF2-40B4-BE49-F238E27FC236}">
-                <a16:creationId xmlns:a16="http://schemas.microsoft.com/office/drawing/2014/main" id="{CCD8DD41-DBDC-4708-9F83-AF51670EF2AE}"/>
+                <a16:creationId xmlns:a16="http://schemas.microsoft.com/office/drawing/2014/main" id="{F5D16493-236D-4CB3-9009-5BB3EE513A67}"/>
               </a:ext>
             </a:extLst>
           </p:cNvPr>
@@ -7158,7 +7158,7 @@
           <p:cNvPr id="24" name="">
             <a:extLst xmlns:a="http://schemas.openxmlformats.org/drawingml/2006/main">
               <a:ext uri="{FF2B5EF4-FFF2-40B4-BE49-F238E27FC236}">
-                <a16:creationId xmlns:a16="http://schemas.microsoft.com/office/drawing/2014/main" id="{6DDB1D82-8AD2-4AA6-A949-14630861A0B0}"/>
+                <a16:creationId xmlns:a16="http://schemas.microsoft.com/office/drawing/2014/main" id="{17FA4FF5-1AB8-484C-96B7-305AE0D8D055}"/>
               </a:ext>
             </a:extLst>
           </p:cNvPr>
@@ -7189,7 +7189,7 @@
           <p:cNvPr id="25" name="">
             <a:extLst xmlns:a="http://schemas.openxmlformats.org/drawingml/2006/main">
               <a:ext uri="{FF2B5EF4-FFF2-40B4-BE49-F238E27FC236}">
-                <a16:creationId xmlns:a16="http://schemas.microsoft.com/office/drawing/2014/main" id="{A409705C-9BAF-495D-8B7D-87BDE5B80605}"/>
+                <a16:creationId xmlns:a16="http://schemas.microsoft.com/office/drawing/2014/main" id="{75A90775-211E-410D-BA93-64706E0A7B25}"/>
               </a:ext>
             </a:extLst>
           </p:cNvPr>
@@ -7222,7 +7222,7 @@
           <p:cNvPr id="26" name="">
             <a:extLst xmlns:a="http://schemas.openxmlformats.org/drawingml/2006/main">
               <a:ext uri="{FF2B5EF4-FFF2-40B4-BE49-F238E27FC236}">
-                <a16:creationId xmlns:a16="http://schemas.microsoft.com/office/drawing/2014/main" id="{2370E123-5E9C-45EF-B26F-B9E32CB6A9A1}"/>
+                <a16:creationId xmlns:a16="http://schemas.microsoft.com/office/drawing/2014/main" id="{96E942E6-D629-41DB-B9E3-642FA98CBF06}"/>
               </a:ext>
             </a:extLst>
           </p:cNvPr>
@@ -7272,7 +7272,7 @@
           <p:cNvPr id="27" name="">
             <a:extLst xmlns:a="http://schemas.openxmlformats.org/drawingml/2006/main">
               <a:ext uri="{FF2B5EF4-FFF2-40B4-BE49-F238E27FC236}">
-                <a16:creationId xmlns:a16="http://schemas.microsoft.com/office/drawing/2014/main" id="{42906D23-48FA-40D1-A609-2731D1AE4CCC}"/>
+                <a16:creationId xmlns:a16="http://schemas.microsoft.com/office/drawing/2014/main" id="{05CFA174-3838-4B1E-B9C6-679926122120}"/>
               </a:ext>
             </a:extLst>
           </p:cNvPr>
@@ -7320,7 +7320,7 @@
     </p:spTree>
     <p:extLst>
       <p:ext uri="{BB962C8B-B14F-4D97-AF65-F5344CB8AC3E}">
-        <p14:creationId xmlns:p14="http://schemas.microsoft.com/office/powerpoint/2010/main" val="1131372143"/>
+        <p14:creationId xmlns:p14="http://schemas.microsoft.com/office/powerpoint/2010/main" val="652865014"/>
       </p:ext>
     </p:extLst>
   </p:cSld>
@@ -7351,7 +7351,7 @@
           <p:cNvPr id="34" name="">
             <a:extLst xmlns:a="http://schemas.openxmlformats.org/drawingml/2006/main">
               <a:ext uri="{FF2B5EF4-FFF2-40B4-BE49-F238E27FC236}">
-                <a16:creationId xmlns:a16="http://schemas.microsoft.com/office/drawing/2014/main" id="{5C4CDBF2-F8AB-46BC-A5BD-5087F74FB9A6}"/>
+                <a16:creationId xmlns:a16="http://schemas.microsoft.com/office/drawing/2014/main" id="{593C961C-7B4C-4A56-B17C-77425A07648F}"/>
               </a:ext>
             </a:extLst>
           </p:cNvPr>
@@ -7401,7 +7401,7 @@
           <p:cNvPr id="2" name="">
             <a:extLst xmlns:a="http://schemas.openxmlformats.org/drawingml/2006/main">
               <a:ext uri="{FF2B5EF4-FFF2-40B4-BE49-F238E27FC236}">
-                <a16:creationId xmlns:a16="http://schemas.microsoft.com/office/drawing/2014/main" id="{A70223D6-7914-45C6-AFDA-8BD689D427CF}"/>
+                <a16:creationId xmlns:a16="http://schemas.microsoft.com/office/drawing/2014/main" id="{4A1D1E6A-1150-4D70-A891-BA1699774AF0}"/>
               </a:ext>
             </a:extLst>
           </p:cNvPr>
@@ -7451,7 +7451,7 @@
           <p:cNvPr id="3" name="">
             <a:extLst xmlns:a="http://schemas.openxmlformats.org/drawingml/2006/main">
               <a:ext uri="{FF2B5EF4-FFF2-40B4-BE49-F238E27FC236}">
-                <a16:creationId xmlns:a16="http://schemas.microsoft.com/office/drawing/2014/main" id="{66F60730-3344-4255-8FC8-87BB986CBE11}"/>
+                <a16:creationId xmlns:a16="http://schemas.microsoft.com/office/drawing/2014/main" id="{1F3035EE-90FF-4579-B9D4-B3519B21ED12}"/>
               </a:ext>
             </a:extLst>
           </p:cNvPr>
@@ -7501,7 +7501,7 @@
           <p:cNvPr id="4" name="">
             <a:extLst xmlns:a="http://schemas.openxmlformats.org/drawingml/2006/main">
               <a:ext uri="{FF2B5EF4-FFF2-40B4-BE49-F238E27FC236}">
-                <a16:creationId xmlns:a16="http://schemas.microsoft.com/office/drawing/2014/main" id="{CA390623-CA9C-41D2-9AFB-9392288262F3}"/>
+                <a16:creationId xmlns:a16="http://schemas.microsoft.com/office/drawing/2014/main" id="{91B00CDB-6214-4CBF-BD5E-412690AC53F6}"/>
               </a:ext>
             </a:extLst>
           </p:cNvPr>
@@ -7532,7 +7532,7 @@
           <p:cNvPr id="5" name="">
             <a:extLst xmlns:a="http://schemas.openxmlformats.org/drawingml/2006/main">
               <a:ext uri="{FF2B5EF4-FFF2-40B4-BE49-F238E27FC236}">
-                <a16:creationId xmlns:a16="http://schemas.microsoft.com/office/drawing/2014/main" id="{A85CFD81-8C38-45C7-B0ED-82F69A048672}"/>
+                <a16:creationId xmlns:a16="http://schemas.microsoft.com/office/drawing/2014/main" id="{E2C38DF5-6A13-4E87-9FBB-2B2F9DD7159A}"/>
               </a:ext>
             </a:extLst>
           </p:cNvPr>
@@ -7565,7 +7565,7 @@
           <p:cNvPr id="6" name="">
             <a:extLst xmlns:a="http://schemas.openxmlformats.org/drawingml/2006/main">
               <a:ext uri="{FF2B5EF4-FFF2-40B4-BE49-F238E27FC236}">
-                <a16:creationId xmlns:a16="http://schemas.microsoft.com/office/drawing/2014/main" id="{41689AE1-5D51-4DF3-9FBC-B1D7E01BAD86}"/>
+                <a16:creationId xmlns:a16="http://schemas.microsoft.com/office/drawing/2014/main" id="{4E7BDCB1-95E0-45C7-B81D-2EA4E0EFFA7A}"/>
               </a:ext>
             </a:extLst>
           </p:cNvPr>
@@ -7615,7 +7615,7 @@
           <p:cNvPr id="7" name="">
             <a:extLst xmlns:a="http://schemas.openxmlformats.org/drawingml/2006/main">
               <a:ext uri="{FF2B5EF4-FFF2-40B4-BE49-F238E27FC236}">
-                <a16:creationId xmlns:a16="http://schemas.microsoft.com/office/drawing/2014/main" id="{0A4115E9-9037-42DF-9997-1FB5D9D67FF7}"/>
+                <a16:creationId xmlns:a16="http://schemas.microsoft.com/office/drawing/2014/main" id="{24929647-E6EE-434C-91E0-8231A742A329}"/>
               </a:ext>
             </a:extLst>
           </p:cNvPr>
@@ -7646,7 +7646,7 @@
           <p:cNvPr id="8" name="">
             <a:extLst xmlns:a="http://schemas.openxmlformats.org/drawingml/2006/main">
               <a:ext uri="{FF2B5EF4-FFF2-40B4-BE49-F238E27FC236}">
-                <a16:creationId xmlns:a16="http://schemas.microsoft.com/office/drawing/2014/main" id="{7E282AD3-4A72-4621-BABD-F9C47C4D21BC}"/>
+                <a16:creationId xmlns:a16="http://schemas.microsoft.com/office/drawing/2014/main" id="{298A61EE-42BE-4C9D-9A21-47E4539B565B}"/>
               </a:ext>
             </a:extLst>
           </p:cNvPr>
@@ -7677,7 +7677,7 @@
           <p:cNvPr id="9" name="">
             <a:extLst xmlns:a="http://schemas.openxmlformats.org/drawingml/2006/main">
               <a:ext uri="{FF2B5EF4-FFF2-40B4-BE49-F238E27FC236}">
-                <a16:creationId xmlns:a16="http://schemas.microsoft.com/office/drawing/2014/main" id="{A66B740F-45AE-4052-B20B-0323AECE50FF}"/>
+                <a16:creationId xmlns:a16="http://schemas.microsoft.com/office/drawing/2014/main" id="{71611742-F4CF-4393-8A3E-6901DBB188FF}"/>
               </a:ext>
             </a:extLst>
           </p:cNvPr>
@@ -7708,7 +7708,7 @@
           <p:cNvPr id="10" name="">
             <a:extLst xmlns:a="http://schemas.openxmlformats.org/drawingml/2006/main">
               <a:ext uri="{FF2B5EF4-FFF2-40B4-BE49-F238E27FC236}">
-                <a16:creationId xmlns:a16="http://schemas.microsoft.com/office/drawing/2014/main" id="{644C0374-0A71-447C-A751-A540DD882095}"/>
+                <a16:creationId xmlns:a16="http://schemas.microsoft.com/office/drawing/2014/main" id="{C9BB77A7-B8E7-4267-A80D-081D0C18362A}"/>
               </a:ext>
             </a:extLst>
           </p:cNvPr>
@@ -7739,7 +7739,7 @@
           <p:cNvPr id="11" name="">
             <a:extLst xmlns:a="http://schemas.openxmlformats.org/drawingml/2006/main">
               <a:ext uri="{FF2B5EF4-FFF2-40B4-BE49-F238E27FC236}">
-                <a16:creationId xmlns:a16="http://schemas.microsoft.com/office/drawing/2014/main" id="{1441F77F-6436-48DB-8AE7-2880487ED8DD}"/>
+                <a16:creationId xmlns:a16="http://schemas.microsoft.com/office/drawing/2014/main" id="{20119D71-ED41-4350-88CE-61CDCAA73DDD}"/>
               </a:ext>
             </a:extLst>
           </p:cNvPr>
@@ -7770,7 +7770,7 @@
           <p:cNvPr id="12" name="">
             <a:extLst xmlns:a="http://schemas.openxmlformats.org/drawingml/2006/main">
               <a:ext uri="{FF2B5EF4-FFF2-40B4-BE49-F238E27FC236}">
-                <a16:creationId xmlns:a16="http://schemas.microsoft.com/office/drawing/2014/main" id="{AF9EC1ED-AF0B-4A1C-AA7F-8CF0E0FB52F7}"/>
+                <a16:creationId xmlns:a16="http://schemas.microsoft.com/office/drawing/2014/main" id="{BDFCD460-27F6-4772-A0F8-8DF1E39E25FE}"/>
               </a:ext>
             </a:extLst>
           </p:cNvPr>
@@ -7801,7 +7801,7 @@
           <p:cNvPr id="13" name="">
             <a:extLst xmlns:a="http://schemas.openxmlformats.org/drawingml/2006/main">
               <a:ext uri="{FF2B5EF4-FFF2-40B4-BE49-F238E27FC236}">
-                <a16:creationId xmlns:a16="http://schemas.microsoft.com/office/drawing/2014/main" id="{29A8D91F-2569-4546-8FD3-E0CDA901AACA}"/>
+                <a16:creationId xmlns:a16="http://schemas.microsoft.com/office/drawing/2014/main" id="{BA2F166A-7A30-4BBC-B7F6-ABE41646AEBF}"/>
               </a:ext>
             </a:extLst>
           </p:cNvPr>
@@ -7836,7 +7836,7 @@
           <p:cNvPr id="14" name="">
             <a:extLst xmlns:a="http://schemas.openxmlformats.org/drawingml/2006/main">
               <a:ext uri="{FF2B5EF4-FFF2-40B4-BE49-F238E27FC236}">
-                <a16:creationId xmlns:a16="http://schemas.microsoft.com/office/drawing/2014/main" id="{144A0A44-EFF6-4D5F-8E27-4C127E7D6A49}"/>
+                <a16:creationId xmlns:a16="http://schemas.microsoft.com/office/drawing/2014/main" id="{150E1DEC-737B-425F-B3A9-A2863AC6446E}"/>
               </a:ext>
             </a:extLst>
           </p:cNvPr>
@@ -7886,7 +7886,7 @@
           <p:cNvPr id="15" name="">
             <a:extLst xmlns:a="http://schemas.openxmlformats.org/drawingml/2006/main">
               <a:ext uri="{FF2B5EF4-FFF2-40B4-BE49-F238E27FC236}">
-                <a16:creationId xmlns:a16="http://schemas.microsoft.com/office/drawing/2014/main" id="{64E3E6F6-A3BD-446A-B714-CAE080BE04B4}"/>
+                <a16:creationId xmlns:a16="http://schemas.microsoft.com/office/drawing/2014/main" id="{5B1E07E3-0A71-4A49-A5AA-711161E4255B}"/>
               </a:ext>
             </a:extLst>
           </p:cNvPr>
@@ -7936,7 +7936,7 @@
           <p:cNvPr id="16" name="">
             <a:extLst xmlns:a="http://schemas.openxmlformats.org/drawingml/2006/main">
               <a:ext uri="{FF2B5EF4-FFF2-40B4-BE49-F238E27FC236}">
-                <a16:creationId xmlns:a16="http://schemas.microsoft.com/office/drawing/2014/main" id="{9755EBC3-1768-4755-8881-A390CC038EEB}"/>
+                <a16:creationId xmlns:a16="http://schemas.microsoft.com/office/drawing/2014/main" id="{210BB930-4870-43D5-AB9B-B79F049A3432}"/>
               </a:ext>
             </a:extLst>
           </p:cNvPr>
@@ -7971,7 +7971,7 @@
           <p:cNvPr id="17" name="">
             <a:extLst xmlns:a="http://schemas.openxmlformats.org/drawingml/2006/main">
               <a:ext uri="{FF2B5EF4-FFF2-40B4-BE49-F238E27FC236}">
-                <a16:creationId xmlns:a16="http://schemas.microsoft.com/office/drawing/2014/main" id="{42C29953-61C6-4867-A5DD-5FCA8D3EC9D0}"/>
+                <a16:creationId xmlns:a16="http://schemas.microsoft.com/office/drawing/2014/main" id="{D94540A2-5B3E-4E01-BE2E-C1EA7505DEAE}"/>
               </a:ext>
             </a:extLst>
           </p:cNvPr>
@@ -8021,7 +8021,7 @@
           <p:cNvPr id="18" name="">
             <a:extLst xmlns:a="http://schemas.openxmlformats.org/drawingml/2006/main">
               <a:ext uri="{FF2B5EF4-FFF2-40B4-BE49-F238E27FC236}">
-                <a16:creationId xmlns:a16="http://schemas.microsoft.com/office/drawing/2014/main" id="{D370995B-14CC-42EC-A882-50B2FF06A22C}"/>
+                <a16:creationId xmlns:a16="http://schemas.microsoft.com/office/drawing/2014/main" id="{F3111E35-0F24-4B04-B8C4-3DD74082A8EF}"/>
               </a:ext>
             </a:extLst>
           </p:cNvPr>
@@ -8071,7 +8071,7 @@
           <p:cNvPr id="19" name="">
             <a:extLst xmlns:a="http://schemas.openxmlformats.org/drawingml/2006/main">
               <a:ext uri="{FF2B5EF4-FFF2-40B4-BE49-F238E27FC236}">
-                <a16:creationId xmlns:a16="http://schemas.microsoft.com/office/drawing/2014/main" id="{726C2E0B-0931-46F8-BA12-6362F687E46B}"/>
+                <a16:creationId xmlns:a16="http://schemas.microsoft.com/office/drawing/2014/main" id="{100DEA61-C9CC-4FF1-8953-462670AE7571}"/>
               </a:ext>
             </a:extLst>
           </p:cNvPr>
@@ -8106,7 +8106,7 @@
           <p:cNvPr id="20" name="">
             <a:extLst xmlns:a="http://schemas.openxmlformats.org/drawingml/2006/main">
               <a:ext uri="{FF2B5EF4-FFF2-40B4-BE49-F238E27FC236}">
-                <a16:creationId xmlns:a16="http://schemas.microsoft.com/office/drawing/2014/main" id="{87D7F9C3-A8FB-485D-9F02-C8196798A17D}"/>
+                <a16:creationId xmlns:a16="http://schemas.microsoft.com/office/drawing/2014/main" id="{CB8127E2-F19E-483C-8AB4-A0948BCEA37A}"/>
               </a:ext>
             </a:extLst>
           </p:cNvPr>
@@ -8156,7 +8156,7 @@
           <p:cNvPr id="21" name="">
             <a:extLst xmlns:a="http://schemas.openxmlformats.org/drawingml/2006/main">
               <a:ext uri="{FF2B5EF4-FFF2-40B4-BE49-F238E27FC236}">
-                <a16:creationId xmlns:a16="http://schemas.microsoft.com/office/drawing/2014/main" id="{1DA7F7CF-157C-40CC-8EF1-1CB809E82B35}"/>
+                <a16:creationId xmlns:a16="http://schemas.microsoft.com/office/drawing/2014/main" id="{7C943024-AD28-4239-AAAD-55B0D6BE50C1}"/>
               </a:ext>
             </a:extLst>
           </p:cNvPr>
@@ -8206,7 +8206,7 @@
           <p:cNvPr id="22" name="">
             <a:extLst xmlns:a="http://schemas.openxmlformats.org/drawingml/2006/main">
               <a:ext uri="{FF2B5EF4-FFF2-40B4-BE49-F238E27FC236}">
-                <a16:creationId xmlns:a16="http://schemas.microsoft.com/office/drawing/2014/main" id="{81B1A70B-06BD-46F3-8DCD-10ED3579DCD0}"/>
+                <a16:creationId xmlns:a16="http://schemas.microsoft.com/office/drawing/2014/main" id="{B6EAF5B0-26BD-4B64-88E0-AD6C21DF9B99}"/>
               </a:ext>
             </a:extLst>
           </p:cNvPr>
@@ -8241,7 +8241,7 @@
           <p:cNvPr id="23" name="">
             <a:extLst xmlns:a="http://schemas.openxmlformats.org/drawingml/2006/main">
               <a:ext uri="{FF2B5EF4-FFF2-40B4-BE49-F238E27FC236}">
-                <a16:creationId xmlns:a16="http://schemas.microsoft.com/office/drawing/2014/main" id="{C43DF9AF-34AF-4B64-9A25-B3E431457EB8}"/>
+                <a16:creationId xmlns:a16="http://schemas.microsoft.com/office/drawing/2014/main" id="{54AF0DD9-06D8-47C8-91D8-683087665DFC}"/>
               </a:ext>
             </a:extLst>
           </p:cNvPr>
@@ -8291,7 +8291,7 @@
           <p:cNvPr id="24" name="">
             <a:extLst xmlns:a="http://schemas.openxmlformats.org/drawingml/2006/main">
               <a:ext uri="{FF2B5EF4-FFF2-40B4-BE49-F238E27FC236}">
-                <a16:creationId xmlns:a16="http://schemas.microsoft.com/office/drawing/2014/main" id="{7DAE7D0F-7B7D-44BF-B9FB-4335B72DCC11}"/>
+                <a16:creationId xmlns:a16="http://schemas.microsoft.com/office/drawing/2014/main" id="{05C90344-0143-4EA5-AA6B-F2CDD4708520}"/>
               </a:ext>
             </a:extLst>
           </p:cNvPr>
@@ -8341,7 +8341,7 @@
           <p:cNvPr id="25" name="">
             <a:extLst xmlns:a="http://schemas.openxmlformats.org/drawingml/2006/main">
               <a:ext uri="{FF2B5EF4-FFF2-40B4-BE49-F238E27FC236}">
-                <a16:creationId xmlns:a16="http://schemas.microsoft.com/office/drawing/2014/main" id="{910D574C-07EF-4B0B-A4AA-FE7C119F52FA}"/>
+                <a16:creationId xmlns:a16="http://schemas.microsoft.com/office/drawing/2014/main" id="{C15A94E8-B8FD-4172-9820-80B40D446455}"/>
               </a:ext>
             </a:extLst>
           </p:cNvPr>
@@ -8374,7 +8374,7 @@
           <p:cNvPr id="26" name="">
             <a:extLst xmlns:a="http://schemas.openxmlformats.org/drawingml/2006/main">
               <a:ext uri="{FF2B5EF4-FFF2-40B4-BE49-F238E27FC236}">
-                <a16:creationId xmlns:a16="http://schemas.microsoft.com/office/drawing/2014/main" id="{53F6A448-5B19-4D8B-AA55-C12DD9107882}"/>
+                <a16:creationId xmlns:a16="http://schemas.microsoft.com/office/drawing/2014/main" id="{6E67D029-C8BA-4152-A589-2C61A4C6618A}"/>
               </a:ext>
             </a:extLst>
           </p:cNvPr>
@@ -8424,7 +8424,7 @@
           <p:cNvPr id="27" name="">
             <a:extLst xmlns:a="http://schemas.openxmlformats.org/drawingml/2006/main">
               <a:ext uri="{FF2B5EF4-FFF2-40B4-BE49-F238E27FC236}">
-                <a16:creationId xmlns:a16="http://schemas.microsoft.com/office/drawing/2014/main" id="{83D60C5A-031A-4AA2-B43E-53FFE2BA906A}"/>
+                <a16:creationId xmlns:a16="http://schemas.microsoft.com/office/drawing/2014/main" id="{05148FB8-6DDB-4CA4-8F39-9548B0A07115}"/>
               </a:ext>
             </a:extLst>
           </p:cNvPr>
@@ -8474,7 +8474,7 @@
           <p:cNvPr id="28" name="">
             <a:extLst xmlns:a="http://schemas.openxmlformats.org/drawingml/2006/main">
               <a:ext uri="{FF2B5EF4-FFF2-40B4-BE49-F238E27FC236}">
-                <a16:creationId xmlns:a16="http://schemas.microsoft.com/office/drawing/2014/main" id="{ADED7777-511A-4274-B02F-B8958195D840}"/>
+                <a16:creationId xmlns:a16="http://schemas.microsoft.com/office/drawing/2014/main" id="{9ED147CE-956C-4745-B520-72BBBFC38E26}"/>
               </a:ext>
             </a:extLst>
           </p:cNvPr>
@@ -8524,7 +8524,7 @@
           <p:cNvPr id="29" name="">
             <a:extLst xmlns:a="http://schemas.openxmlformats.org/drawingml/2006/main">
               <a:ext uri="{FF2B5EF4-FFF2-40B4-BE49-F238E27FC236}">
-                <a16:creationId xmlns:a16="http://schemas.microsoft.com/office/drawing/2014/main" id="{C7173903-297E-46DB-B5CA-32B5A8E92280}"/>
+                <a16:creationId xmlns:a16="http://schemas.microsoft.com/office/drawing/2014/main" id="{555B1203-CFC8-439F-850E-A51E73487F00}"/>
               </a:ext>
             </a:extLst>
           </p:cNvPr>
@@ -8574,7 +8574,7 @@
           <p:cNvPr id="30" name="">
             <a:extLst xmlns:a="http://schemas.openxmlformats.org/drawingml/2006/main">
               <a:ext uri="{FF2B5EF4-FFF2-40B4-BE49-F238E27FC236}">
-                <a16:creationId xmlns:a16="http://schemas.microsoft.com/office/drawing/2014/main" id="{D22303D0-2684-413A-A6CF-392C97AEB0E8}"/>
+                <a16:creationId xmlns:a16="http://schemas.microsoft.com/office/drawing/2014/main" id="{B0D83072-B69E-4E51-8D09-F596134E7EA8}"/>
               </a:ext>
             </a:extLst>
           </p:cNvPr>
@@ -8624,7 +8624,7 @@
           <p:cNvPr id="31" name="">
             <a:extLst xmlns:a="http://schemas.openxmlformats.org/drawingml/2006/main">
               <a:ext uri="{FF2B5EF4-FFF2-40B4-BE49-F238E27FC236}">
-                <a16:creationId xmlns:a16="http://schemas.microsoft.com/office/drawing/2014/main" id="{E8061842-4B73-42A9-895B-16ACAABBA722}"/>
+                <a16:creationId xmlns:a16="http://schemas.microsoft.com/office/drawing/2014/main" id="{9DCF2F79-D5C0-4935-82F8-908F375B9231}"/>
               </a:ext>
             </a:extLst>
           </p:cNvPr>
@@ -8708,7 +8708,7 @@
           <p:cNvPr id="32" name="">
             <a:extLst xmlns:a="http://schemas.openxmlformats.org/drawingml/2006/main">
               <a:ext uri="{FF2B5EF4-FFF2-40B4-BE49-F238E27FC236}">
-                <a16:creationId xmlns:a16="http://schemas.microsoft.com/office/drawing/2014/main" id="{82573A18-E4FA-4AFA-B60B-D3BBA0E14D37}"/>
+                <a16:creationId xmlns:a16="http://schemas.microsoft.com/office/drawing/2014/main" id="{200E9046-5171-40AB-87FA-ABAEAF7FFE76}"/>
               </a:ext>
             </a:extLst>
           </p:cNvPr>
@@ -8758,7 +8758,7 @@
           <p:cNvPr id="33" name="">
             <a:extLst xmlns:a="http://schemas.openxmlformats.org/drawingml/2006/main">
               <a:ext uri="{FF2B5EF4-FFF2-40B4-BE49-F238E27FC236}">
-                <a16:creationId xmlns:a16="http://schemas.microsoft.com/office/drawing/2014/main" id="{9F5EC92A-9BBE-4B80-A76C-05715840E159}"/>
+                <a16:creationId xmlns:a16="http://schemas.microsoft.com/office/drawing/2014/main" id="{F616F832-5D91-42E0-B4C5-128AB3DEC28A}"/>
               </a:ext>
             </a:extLst>
           </p:cNvPr>
@@ -8823,7 +8823,7 @@
     </p:spTree>
     <p:extLst>
       <p:ext uri="{BB962C8B-B14F-4D97-AF65-F5344CB8AC3E}">
-        <p14:creationId xmlns:p14="http://schemas.microsoft.com/office/powerpoint/2010/main" val="1844903171"/>
+        <p14:creationId xmlns:p14="http://schemas.microsoft.com/office/powerpoint/2010/main" val="1359579636"/>
       </p:ext>
     </p:extLst>
   </p:cSld>
@@ -8854,7 +8854,7 @@
           <p:cNvPr id="23" name="">
             <a:extLst xmlns:a="http://schemas.openxmlformats.org/drawingml/2006/main">
               <a:ext uri="{FF2B5EF4-FFF2-40B4-BE49-F238E27FC236}">
-                <a16:creationId xmlns:a16="http://schemas.microsoft.com/office/drawing/2014/main" id="{C65BE9B2-AE78-4F9F-AD12-8463BA19B223}"/>
+                <a16:creationId xmlns:a16="http://schemas.microsoft.com/office/drawing/2014/main" id="{CDC7CCB9-1308-4EFE-9029-A5D09594FED9}"/>
               </a:ext>
             </a:extLst>
           </p:cNvPr>
@@ -8904,7 +8904,7 @@
           <p:cNvPr id="2" name="">
             <a:extLst xmlns:a="http://schemas.openxmlformats.org/drawingml/2006/main">
               <a:ext uri="{FF2B5EF4-FFF2-40B4-BE49-F238E27FC236}">
-                <a16:creationId xmlns:a16="http://schemas.microsoft.com/office/drawing/2014/main" id="{7C4DDE60-492F-4335-A376-17B020733783}"/>
+                <a16:creationId xmlns:a16="http://schemas.microsoft.com/office/drawing/2014/main" id="{A4572E91-E1C1-4F3B-B436-33EDFF0B3B5A}"/>
               </a:ext>
             </a:extLst>
           </p:cNvPr>
@@ -8954,7 +8954,7 @@
           <p:cNvPr id="3" name="">
             <a:extLst xmlns:a="http://schemas.openxmlformats.org/drawingml/2006/main">
               <a:ext uri="{FF2B5EF4-FFF2-40B4-BE49-F238E27FC236}">
-                <a16:creationId xmlns:a16="http://schemas.microsoft.com/office/drawing/2014/main" id="{5B2D1AC2-11CA-44B2-8E00-3B4CDAC30DCA}"/>
+                <a16:creationId xmlns:a16="http://schemas.microsoft.com/office/drawing/2014/main" id="{CAC598B1-FE5C-4346-B88B-5ACCF674DC14}"/>
               </a:ext>
             </a:extLst>
           </p:cNvPr>
@@ -9004,7 +9004,7 @@
           <p:cNvPr id="4" name="">
             <a:extLst xmlns:a="http://schemas.openxmlformats.org/drawingml/2006/main">
               <a:ext uri="{FF2B5EF4-FFF2-40B4-BE49-F238E27FC236}">
-                <a16:creationId xmlns:a16="http://schemas.microsoft.com/office/drawing/2014/main" id="{CB7989FB-9BDE-4C44-8FB6-F2BD5CED975C}"/>
+                <a16:creationId xmlns:a16="http://schemas.microsoft.com/office/drawing/2014/main" id="{668A3CF1-0E25-45C1-824F-F5D46C057B5B}"/>
               </a:ext>
             </a:extLst>
           </p:cNvPr>
@@ -9035,7 +9035,7 @@
           <p:cNvPr id="5" name="">
             <a:extLst xmlns:a="http://schemas.openxmlformats.org/drawingml/2006/main">
               <a:ext uri="{FF2B5EF4-FFF2-40B4-BE49-F238E27FC236}">
-                <a16:creationId xmlns:a16="http://schemas.microsoft.com/office/drawing/2014/main" id="{96260870-5DA8-4EB8-875D-A90E204BD5A8}"/>
+                <a16:creationId xmlns:a16="http://schemas.microsoft.com/office/drawing/2014/main" id="{C3971761-F439-44BC-8160-582D7D1C2CF8}"/>
               </a:ext>
             </a:extLst>
           </p:cNvPr>
@@ -9085,7 +9085,7 @@
           <p:cNvPr id="6" name="">
             <a:extLst xmlns:a="http://schemas.openxmlformats.org/drawingml/2006/main">
               <a:ext uri="{FF2B5EF4-FFF2-40B4-BE49-F238E27FC236}">
-                <a16:creationId xmlns:a16="http://schemas.microsoft.com/office/drawing/2014/main" id="{51274377-B6F4-42B9-9259-642B5D442E32}"/>
+                <a16:creationId xmlns:a16="http://schemas.microsoft.com/office/drawing/2014/main" id="{4D317ED8-B0CA-4FF1-AB20-23DF929B1E57}"/>
               </a:ext>
             </a:extLst>
           </p:cNvPr>
@@ -9152,7 +9152,7 @@
           <p:cNvPr id="7" name="">
             <a:extLst xmlns:a="http://schemas.openxmlformats.org/drawingml/2006/main">
               <a:ext uri="{FF2B5EF4-FFF2-40B4-BE49-F238E27FC236}">
-                <a16:creationId xmlns:a16="http://schemas.microsoft.com/office/drawing/2014/main" id="{27F52866-3873-4666-902E-76068EA14D20}"/>
+                <a16:creationId xmlns:a16="http://schemas.microsoft.com/office/drawing/2014/main" id="{E4FB0BF6-5E92-4AD0-9F64-1FA75405411D}"/>
               </a:ext>
             </a:extLst>
           </p:cNvPr>
@@ -9202,7 +9202,7 @@
           <p:cNvPr id="8" name="">
             <a:extLst xmlns:a="http://schemas.openxmlformats.org/drawingml/2006/main">
               <a:ext uri="{FF2B5EF4-FFF2-40B4-BE49-F238E27FC236}">
-                <a16:creationId xmlns:a16="http://schemas.microsoft.com/office/drawing/2014/main" id="{260A50A9-6566-40A3-9F90-F309C996E819}"/>
+                <a16:creationId xmlns:a16="http://schemas.microsoft.com/office/drawing/2014/main" id="{E246C3DC-57E9-4F7C-8409-34AE8954DD1C}"/>
               </a:ext>
             </a:extLst>
           </p:cNvPr>
@@ -9269,7 +9269,7 @@
           <p:cNvPr id="9" name="">
             <a:extLst xmlns:a="http://schemas.openxmlformats.org/drawingml/2006/main">
               <a:ext uri="{FF2B5EF4-FFF2-40B4-BE49-F238E27FC236}">
-                <a16:creationId xmlns:a16="http://schemas.microsoft.com/office/drawing/2014/main" id="{B955712A-0DB3-4B85-9A0B-5EDC974B7661}"/>
+                <a16:creationId xmlns:a16="http://schemas.microsoft.com/office/drawing/2014/main" id="{3875ED1A-CE8D-45BE-8A24-74BD6F84D99F}"/>
               </a:ext>
             </a:extLst>
           </p:cNvPr>
@@ -9319,7 +9319,7 @@
           <p:cNvPr id="10" name="">
             <a:extLst xmlns:a="http://schemas.openxmlformats.org/drawingml/2006/main">
               <a:ext uri="{FF2B5EF4-FFF2-40B4-BE49-F238E27FC236}">
-                <a16:creationId xmlns:a16="http://schemas.microsoft.com/office/drawing/2014/main" id="{927D6154-5043-4A65-AFE8-831A9512B09F}"/>
+                <a16:creationId xmlns:a16="http://schemas.microsoft.com/office/drawing/2014/main" id="{7D0A0566-D67F-4798-852E-7E0E01BD3B41}"/>
               </a:ext>
             </a:extLst>
           </p:cNvPr>
@@ -9403,7 +9403,7 @@
           <p:cNvPr id="11" name="">
             <a:extLst xmlns:a="http://schemas.openxmlformats.org/drawingml/2006/main">
               <a:ext uri="{FF2B5EF4-FFF2-40B4-BE49-F238E27FC236}">
-                <a16:creationId xmlns:a16="http://schemas.microsoft.com/office/drawing/2014/main" id="{E401C290-79DD-4F60-A0C0-4E87E746853D}"/>
+                <a16:creationId xmlns:a16="http://schemas.microsoft.com/office/drawing/2014/main" id="{B850D215-6DA8-4A63-A495-6707440E522A}"/>
               </a:ext>
             </a:extLst>
           </p:cNvPr>
@@ -9434,7 +9434,7 @@
           <p:cNvPr id="12" name="">
             <a:extLst xmlns:a="http://schemas.openxmlformats.org/drawingml/2006/main">
               <a:ext uri="{FF2B5EF4-FFF2-40B4-BE49-F238E27FC236}">
-                <a16:creationId xmlns:a16="http://schemas.microsoft.com/office/drawing/2014/main" id="{262AA1C3-868D-49B7-A18B-6ED51D846671}"/>
+                <a16:creationId xmlns:a16="http://schemas.microsoft.com/office/drawing/2014/main" id="{017B31C4-57BB-4FBD-8C87-9AF2E001FF04}"/>
               </a:ext>
             </a:extLst>
           </p:cNvPr>
@@ -9484,7 +9484,7 @@
           <p:cNvPr id="13" name="">
             <a:extLst xmlns:a="http://schemas.openxmlformats.org/drawingml/2006/main">
               <a:ext uri="{FF2B5EF4-FFF2-40B4-BE49-F238E27FC236}">
-                <a16:creationId xmlns:a16="http://schemas.microsoft.com/office/drawing/2014/main" id="{105F3CEE-7923-480C-89EE-56FD85E3EF1D}"/>
+                <a16:creationId xmlns:a16="http://schemas.microsoft.com/office/drawing/2014/main" id="{EC40E08F-09AC-4454-95B6-2F1F40049D93}"/>
               </a:ext>
             </a:extLst>
           </p:cNvPr>
@@ -9534,7 +9534,7 @@
           <p:cNvPr id="14" name="">
             <a:extLst xmlns:a="http://schemas.openxmlformats.org/drawingml/2006/main">
               <a:ext uri="{FF2B5EF4-FFF2-40B4-BE49-F238E27FC236}">
-                <a16:creationId xmlns:a16="http://schemas.microsoft.com/office/drawing/2014/main" id="{D6D69C65-21C2-4B9C-A103-06B1D7503E66}"/>
+                <a16:creationId xmlns:a16="http://schemas.microsoft.com/office/drawing/2014/main" id="{EA116C8E-F82A-4281-8AF5-DD4BEAEED65D}"/>
               </a:ext>
             </a:extLst>
           </p:cNvPr>
@@ -9584,7 +9584,7 @@
           <p:cNvPr id="15" name="">
             <a:extLst xmlns:a="http://schemas.openxmlformats.org/drawingml/2006/main">
               <a:ext uri="{FF2B5EF4-FFF2-40B4-BE49-F238E27FC236}">
-                <a16:creationId xmlns:a16="http://schemas.microsoft.com/office/drawing/2014/main" id="{86B4DF27-54E2-4868-9F40-4EBFE5D61A7C}"/>
+                <a16:creationId xmlns:a16="http://schemas.microsoft.com/office/drawing/2014/main" id="{F8D74293-0F22-4CDD-9419-61F58DB644BA}"/>
               </a:ext>
             </a:extLst>
           </p:cNvPr>
@@ -9634,7 +9634,7 @@
           <p:cNvPr id="16" name="">
             <a:extLst xmlns:a="http://schemas.openxmlformats.org/drawingml/2006/main">
               <a:ext uri="{FF2B5EF4-FFF2-40B4-BE49-F238E27FC236}">
-                <a16:creationId xmlns:a16="http://schemas.microsoft.com/office/drawing/2014/main" id="{D0F4D16B-7D66-4773-8F02-4E5B65CEF92A}"/>
+                <a16:creationId xmlns:a16="http://schemas.microsoft.com/office/drawing/2014/main" id="{7F699DB5-3DEC-457C-BB15-194768EAFFFA}"/>
               </a:ext>
             </a:extLst>
           </p:cNvPr>
@@ -9684,7 +9684,7 @@
           <p:cNvPr id="17" name="">
             <a:extLst xmlns:a="http://schemas.openxmlformats.org/drawingml/2006/main">
               <a:ext uri="{FF2B5EF4-FFF2-40B4-BE49-F238E27FC236}">
-                <a16:creationId xmlns:a16="http://schemas.microsoft.com/office/drawing/2014/main" id="{8A922358-C7A5-4F07-A00A-FCD5429E4BC8}"/>
+                <a16:creationId xmlns:a16="http://schemas.microsoft.com/office/drawing/2014/main" id="{B2745B22-8D53-4F05-AB0F-204A9C057AE1}"/>
               </a:ext>
             </a:extLst>
           </p:cNvPr>
@@ -9734,7 +9734,7 @@
           <p:cNvPr id="18" name="">
             <a:extLst xmlns:a="http://schemas.openxmlformats.org/drawingml/2006/main">
               <a:ext uri="{FF2B5EF4-FFF2-40B4-BE49-F238E27FC236}">
-                <a16:creationId xmlns:a16="http://schemas.microsoft.com/office/drawing/2014/main" id="{2D4DC3FB-AE44-4D70-A58B-CD962C4C4F6F}"/>
+                <a16:creationId xmlns:a16="http://schemas.microsoft.com/office/drawing/2014/main" id="{4BB86AD7-EA16-46A8-8E43-3645DECBF471}"/>
               </a:ext>
             </a:extLst>
           </p:cNvPr>
@@ -9784,7 +9784,7 @@
           <p:cNvPr id="19" name="">
             <a:extLst xmlns:a="http://schemas.openxmlformats.org/drawingml/2006/main">
               <a:ext uri="{FF2B5EF4-FFF2-40B4-BE49-F238E27FC236}">
-                <a16:creationId xmlns:a16="http://schemas.microsoft.com/office/drawing/2014/main" id="{7B7F1C71-D4B0-4A30-A2F9-5C537915BF45}"/>
+                <a16:creationId xmlns:a16="http://schemas.microsoft.com/office/drawing/2014/main" id="{68A4DA14-7BEA-435D-8188-EFB5ADE9A02E}"/>
               </a:ext>
             </a:extLst>
           </p:cNvPr>
@@ -9834,7 +9834,7 @@
           <p:cNvPr id="20" name="">
             <a:extLst xmlns:a="http://schemas.openxmlformats.org/drawingml/2006/main">
               <a:ext uri="{FF2B5EF4-FFF2-40B4-BE49-F238E27FC236}">
-                <a16:creationId xmlns:a16="http://schemas.microsoft.com/office/drawing/2014/main" id="{86799E4F-8477-4C9B-A1FB-97AB63B319BC}"/>
+                <a16:creationId xmlns:a16="http://schemas.microsoft.com/office/drawing/2014/main" id="{2214024A-417C-4FF0-8F52-5A2D39B042A0}"/>
               </a:ext>
             </a:extLst>
           </p:cNvPr>
@@ -9867,7 +9867,7 @@
           <p:cNvPr id="21" name="">
             <a:extLst xmlns:a="http://schemas.openxmlformats.org/drawingml/2006/main">
               <a:ext uri="{FF2B5EF4-FFF2-40B4-BE49-F238E27FC236}">
-                <a16:creationId xmlns:a16="http://schemas.microsoft.com/office/drawing/2014/main" id="{9AC8B265-CC4F-412C-A4BD-FCD4B9947D1F}"/>
+                <a16:creationId xmlns:a16="http://schemas.microsoft.com/office/drawing/2014/main" id="{4D738025-016D-4106-B3FD-01E95C71F39D}"/>
               </a:ext>
             </a:extLst>
           </p:cNvPr>
@@ -9917,7 +9917,7 @@
           <p:cNvPr id="22" name="">
             <a:extLst xmlns:a="http://schemas.openxmlformats.org/drawingml/2006/main">
               <a:ext uri="{FF2B5EF4-FFF2-40B4-BE49-F238E27FC236}">
-                <a16:creationId xmlns:a16="http://schemas.microsoft.com/office/drawing/2014/main" id="{A3E09D27-E350-45C7-865A-614A03118455}"/>
+                <a16:creationId xmlns:a16="http://schemas.microsoft.com/office/drawing/2014/main" id="{FDDE6D67-771D-4F43-A220-DA94750DC568}"/>
               </a:ext>
             </a:extLst>
           </p:cNvPr>
@@ -9965,7 +9965,7 @@
     </p:spTree>
     <p:extLst>
       <p:ext uri="{BB962C8B-B14F-4D97-AF65-F5344CB8AC3E}">
-        <p14:creationId xmlns:p14="http://schemas.microsoft.com/office/powerpoint/2010/main" val="395850097"/>
+        <p14:creationId xmlns:p14="http://schemas.microsoft.com/office/powerpoint/2010/main" val="2090813974"/>
       </p:ext>
     </p:extLst>
   </p:cSld>
@@ -9996,7 +9996,7 @@
           <p:cNvPr id="19" name="">
             <a:extLst xmlns:a="http://schemas.openxmlformats.org/drawingml/2006/main">
               <a:ext uri="{FF2B5EF4-FFF2-40B4-BE49-F238E27FC236}">
-                <a16:creationId xmlns:a16="http://schemas.microsoft.com/office/drawing/2014/main" id="{058F0029-F631-4B1E-9721-2D2B9409FC52}"/>
+                <a16:creationId xmlns:a16="http://schemas.microsoft.com/office/drawing/2014/main" id="{F383677D-38FD-48B5-8AF0-902E1890B4C0}"/>
               </a:ext>
             </a:extLst>
           </p:cNvPr>
@@ -10046,7 +10046,7 @@
           <p:cNvPr id="2" name="">
             <a:extLst xmlns:a="http://schemas.openxmlformats.org/drawingml/2006/main">
               <a:ext uri="{FF2B5EF4-FFF2-40B4-BE49-F238E27FC236}">
-                <a16:creationId xmlns:a16="http://schemas.microsoft.com/office/drawing/2014/main" id="{38F37DF5-7C16-4EDA-B5EC-AC16E9666042}"/>
+                <a16:creationId xmlns:a16="http://schemas.microsoft.com/office/drawing/2014/main" id="{463252D2-86F7-4F82-B05E-DA5FCD77A51B}"/>
               </a:ext>
             </a:extLst>
           </p:cNvPr>
@@ -10096,7 +10096,7 @@
           <p:cNvPr id="3" name="">
             <a:extLst xmlns:a="http://schemas.openxmlformats.org/drawingml/2006/main">
               <a:ext uri="{FF2B5EF4-FFF2-40B4-BE49-F238E27FC236}">
-                <a16:creationId xmlns:a16="http://schemas.microsoft.com/office/drawing/2014/main" id="{09078EF5-0672-42FD-8367-E1FEF559BEDC}"/>
+                <a16:creationId xmlns:a16="http://schemas.microsoft.com/office/drawing/2014/main" id="{A5CCB5AC-024B-428D-8230-FF9447F9288E}"/>
               </a:ext>
             </a:extLst>
           </p:cNvPr>
@@ -10146,7 +10146,7 @@
           <p:cNvPr id="4" name="">
             <a:extLst xmlns:a="http://schemas.openxmlformats.org/drawingml/2006/main">
               <a:ext uri="{FF2B5EF4-FFF2-40B4-BE49-F238E27FC236}">
-                <a16:creationId xmlns:a16="http://schemas.microsoft.com/office/drawing/2014/main" id="{70FD8F8C-383F-42B4-B79D-FE4B24A034C4}"/>
+                <a16:creationId xmlns:a16="http://schemas.microsoft.com/office/drawing/2014/main" id="{FDADA866-AAC3-4F50-BFAE-F3456D23FE77}"/>
               </a:ext>
             </a:extLst>
           </p:cNvPr>
@@ -10177,7 +10177,7 @@
           <p:cNvPr id="5" name="">
             <a:extLst xmlns:a="http://schemas.openxmlformats.org/drawingml/2006/main">
               <a:ext uri="{FF2B5EF4-FFF2-40B4-BE49-F238E27FC236}">
-                <a16:creationId xmlns:a16="http://schemas.microsoft.com/office/drawing/2014/main" id="{1EEFDF07-5725-4CFD-86B2-AC56C585D434}"/>
+                <a16:creationId xmlns:a16="http://schemas.microsoft.com/office/drawing/2014/main" id="{5134706D-30C0-4734-970C-841248C3CD78}"/>
               </a:ext>
             </a:extLst>
           </p:cNvPr>
@@ -10227,7 +10227,7 @@
           <p:cNvPr id="6" name="">
             <a:extLst xmlns:a="http://schemas.openxmlformats.org/drawingml/2006/main">
               <a:ext uri="{FF2B5EF4-FFF2-40B4-BE49-F238E27FC236}">
-                <a16:creationId xmlns:a16="http://schemas.microsoft.com/office/drawing/2014/main" id="{E0FF1AA0-57EC-42E0-AE9C-FE5D98D90B8D}"/>
+                <a16:creationId xmlns:a16="http://schemas.microsoft.com/office/drawing/2014/main" id="{E7744025-C406-43E3-9C67-69531FA3F858}"/>
               </a:ext>
             </a:extLst>
           </p:cNvPr>
@@ -10294,7 +10294,7 @@
           <p:cNvPr id="7" name="">
             <a:extLst xmlns:a="http://schemas.openxmlformats.org/drawingml/2006/main">
               <a:ext uri="{FF2B5EF4-FFF2-40B4-BE49-F238E27FC236}">
-                <a16:creationId xmlns:a16="http://schemas.microsoft.com/office/drawing/2014/main" id="{FCEB3E67-E32D-4049-88CC-C989ADD86415}"/>
+                <a16:creationId xmlns:a16="http://schemas.microsoft.com/office/drawing/2014/main" id="{D1E222CA-9E42-415E-BF64-0AE23B78FECE}"/>
               </a:ext>
             </a:extLst>
           </p:cNvPr>
@@ -10327,7 +10327,7 @@
           <p:cNvPr id="8" name="">
             <a:extLst xmlns:a="http://schemas.openxmlformats.org/drawingml/2006/main">
               <a:ext uri="{FF2B5EF4-FFF2-40B4-BE49-F238E27FC236}">
-                <a16:creationId xmlns:a16="http://schemas.microsoft.com/office/drawing/2014/main" id="{81F5A155-EBDD-4706-950E-51A79CC7DC8B}"/>
+                <a16:creationId xmlns:a16="http://schemas.microsoft.com/office/drawing/2014/main" id="{35F6E54B-72DE-4962-9D17-2483F715F839}"/>
               </a:ext>
             </a:extLst>
           </p:cNvPr>
@@ -10377,7 +10377,7 @@
           <p:cNvPr id="9" name="">
             <a:extLst xmlns:a="http://schemas.openxmlformats.org/drawingml/2006/main">
               <a:ext uri="{FF2B5EF4-FFF2-40B4-BE49-F238E27FC236}">
-                <a16:creationId xmlns:a16="http://schemas.microsoft.com/office/drawing/2014/main" id="{635FAFE8-5B78-4857-B199-693427143509}"/>
+                <a16:creationId xmlns:a16="http://schemas.microsoft.com/office/drawing/2014/main" id="{D4D93259-2793-40F8-A8C5-F207691DE627}"/>
               </a:ext>
             </a:extLst>
           </p:cNvPr>
@@ -10408,7 +10408,7 @@
           <p:cNvPr id="10" name="">
             <a:extLst xmlns:a="http://schemas.openxmlformats.org/drawingml/2006/main">
               <a:ext uri="{FF2B5EF4-FFF2-40B4-BE49-F238E27FC236}">
-                <a16:creationId xmlns:a16="http://schemas.microsoft.com/office/drawing/2014/main" id="{911BD501-8E51-40B4-997E-FF350D2650B4}"/>
+                <a16:creationId xmlns:a16="http://schemas.microsoft.com/office/drawing/2014/main" id="{F845D647-09C4-47CE-A91E-1BB528BCD91F}"/>
               </a:ext>
             </a:extLst>
           </p:cNvPr>
@@ -10458,7 +10458,7 @@
           <p:cNvPr id="11" name="">
             <a:extLst xmlns:a="http://schemas.openxmlformats.org/drawingml/2006/main">
               <a:ext uri="{FF2B5EF4-FFF2-40B4-BE49-F238E27FC236}">
-                <a16:creationId xmlns:a16="http://schemas.microsoft.com/office/drawing/2014/main" id="{ACDD6E94-AECB-44CA-909A-A03E18DFF3E8}"/>
+                <a16:creationId xmlns:a16="http://schemas.microsoft.com/office/drawing/2014/main" id="{8B515F24-EABB-4352-84DA-3C2009F15C72}"/>
               </a:ext>
             </a:extLst>
           </p:cNvPr>
@@ -10525,7 +10525,7 @@
           <p:cNvPr id="12" name="">
             <a:extLst xmlns:a="http://schemas.openxmlformats.org/drawingml/2006/main">
               <a:ext uri="{FF2B5EF4-FFF2-40B4-BE49-F238E27FC236}">
-                <a16:creationId xmlns:a16="http://schemas.microsoft.com/office/drawing/2014/main" id="{399710BD-DB66-49E0-9DF7-017957F981D7}"/>
+                <a16:creationId xmlns:a16="http://schemas.microsoft.com/office/drawing/2014/main" id="{4D0722EE-C57E-4CA2-88B5-B79FD289D0E8}"/>
               </a:ext>
             </a:extLst>
           </p:cNvPr>
@@ -10575,7 +10575,7 @@
           <p:cNvPr id="13" name="">
             <a:extLst xmlns:a="http://schemas.openxmlformats.org/drawingml/2006/main">
               <a:ext uri="{FF2B5EF4-FFF2-40B4-BE49-F238E27FC236}">
-                <a16:creationId xmlns:a16="http://schemas.microsoft.com/office/drawing/2014/main" id="{F1959773-5150-45F1-8535-97D07BBF3FA4}"/>
+                <a16:creationId xmlns:a16="http://schemas.microsoft.com/office/drawing/2014/main" id="{C144FD8A-ED09-458C-A580-3FC962EBB3C1}"/>
               </a:ext>
             </a:extLst>
           </p:cNvPr>
@@ -10642,7 +10642,7 @@
           <p:cNvPr id="14" name="">
             <a:extLst xmlns:a="http://schemas.openxmlformats.org/drawingml/2006/main">
               <a:ext uri="{FF2B5EF4-FFF2-40B4-BE49-F238E27FC236}">
-                <a16:creationId xmlns:a16="http://schemas.microsoft.com/office/drawing/2014/main" id="{F6B56B01-1622-42B3-A57C-57A32A5C4F2D}"/>
+                <a16:creationId xmlns:a16="http://schemas.microsoft.com/office/drawing/2014/main" id="{2DA4B6ED-D9E5-4872-B562-E3D3E0ED73AA}"/>
               </a:ext>
             </a:extLst>
           </p:cNvPr>
@@ -10692,7 +10692,7 @@
           <p:cNvPr id="15" name="">
             <a:extLst xmlns:a="http://schemas.openxmlformats.org/drawingml/2006/main">
               <a:ext uri="{FF2B5EF4-FFF2-40B4-BE49-F238E27FC236}">
-                <a16:creationId xmlns:a16="http://schemas.microsoft.com/office/drawing/2014/main" id="{DCF75B0A-CDB4-44AC-822A-734F6703EEFC}"/>
+                <a16:creationId xmlns:a16="http://schemas.microsoft.com/office/drawing/2014/main" id="{7374DB9E-88BE-4217-8766-8E483382C183}"/>
               </a:ext>
             </a:extLst>
           </p:cNvPr>
@@ -10759,7 +10759,7 @@
           <p:cNvPr id="16" name="">
             <a:extLst xmlns:a="http://schemas.openxmlformats.org/drawingml/2006/main">
               <a:ext uri="{FF2B5EF4-FFF2-40B4-BE49-F238E27FC236}">
-                <a16:creationId xmlns:a16="http://schemas.microsoft.com/office/drawing/2014/main" id="{3A9B4F84-1FC6-4C5B-91D8-7CD914DC6199}"/>
+                <a16:creationId xmlns:a16="http://schemas.microsoft.com/office/drawing/2014/main" id="{A6FADAC2-E513-42EA-9447-DBAA8906CB63}"/>
               </a:ext>
             </a:extLst>
           </p:cNvPr>
@@ -10792,7 +10792,7 @@
           <p:cNvPr id="17" name="">
             <a:extLst xmlns:a="http://schemas.openxmlformats.org/drawingml/2006/main">
               <a:ext uri="{FF2B5EF4-FFF2-40B4-BE49-F238E27FC236}">
-                <a16:creationId xmlns:a16="http://schemas.microsoft.com/office/drawing/2014/main" id="{6BA3624C-0AE7-4C94-9046-D3F7A1F623B9}"/>
+                <a16:creationId xmlns:a16="http://schemas.microsoft.com/office/drawing/2014/main" id="{FFE18DBB-6006-4068-8C7E-2ABB72F6504A}"/>
               </a:ext>
             </a:extLst>
           </p:cNvPr>
@@ -10842,7 +10842,7 @@
           <p:cNvPr id="18" name="">
             <a:extLst xmlns:a="http://schemas.openxmlformats.org/drawingml/2006/main">
               <a:ext uri="{FF2B5EF4-FFF2-40B4-BE49-F238E27FC236}">
-                <a16:creationId xmlns:a16="http://schemas.microsoft.com/office/drawing/2014/main" id="{0D00F52B-D8C6-42E2-BF77-5327C615AA74}"/>
+                <a16:creationId xmlns:a16="http://schemas.microsoft.com/office/drawing/2014/main" id="{005D046E-D9C4-4DD0-887C-385294A992AB}"/>
               </a:ext>
             </a:extLst>
           </p:cNvPr>
@@ -10890,7 +10890,7 @@
     </p:spTree>
     <p:extLst>
       <p:ext uri="{BB962C8B-B14F-4D97-AF65-F5344CB8AC3E}">
-        <p14:creationId xmlns:p14="http://schemas.microsoft.com/office/powerpoint/2010/main" val="49332209"/>
+        <p14:creationId xmlns:p14="http://schemas.microsoft.com/office/powerpoint/2010/main" val="919935030"/>
       </p:ext>
     </p:extLst>
   </p:cSld>

</xml_diff>